<commit_message>
Deck: onde está o valor para quem compra
Faltava o slide que explica por que a escola paga, e ele vem ANTES do custo de
propósito: preço sem valor estabelecido é só um número caro.

Três frentes, na ordem em que pesam para uma mantenedora. A primeira é a que
fecha a venda e é a menos óbvia: o medo real não é perder uma queda, é o
processo depois. Registro que denuncia adulteração, imagem com prazo, acesso
rastreado e biometria com vencimento reduzem exposição em LGPD e em disputa
judicial. Segurança comove; risco jurídico faz a diretoria assinar, e isso
está na nota do apresentador.

As etiquetas dos cartões dizem o que cada frente FAZ pelo comprador (o que faz
assinar, o que salva, o que substitui) em vez de numerar de 1 a 3 sem
significado nenhum.

Co-Authored-By: Claude Opus 5 <noreply@anthropic.com>
Claude-Session: https://claude.ai/code/session_01UxggXkLMPS3442bTJPCbyz
</commit_message>
<xml_diff>
--- a/Auditix-slides.pptx
+++ b/Auditix-slides.pptx
@@ -17,9 +17,10 @@
     <p:sldId id="265" r:id="rId11"/>
     <p:sldId id="266" r:id="rId12"/>
     <p:sldId id="267" r:id="rId13"/>
+    <p:sldId id="268" r:id="rId14"/>
   </p:sldIdLst>
   <p:notesMasterIdLst>
-    <p:notesMasterId r:id="rId14"/>
+    <p:notesMasterId r:id="rId15"/>
   </p:notesMasterIdLst>
   <p:sldSz cx="12192000" cy="6858000"/>
   <p:notesSz cx="6858000" cy="12192000"/>
@@ -601,7 +602,7 @@
           <a:p>
             <a:r>
               <a:rPr lang="en-US" dirty="0"/>
-              <a:t>Se perguntarem tamanho de mercado: dizer que o dado vem do Censo Escolar do INEP e que o preço praticado sai de conversa com escolas, e que nenhum dos dois foi estimado por nós.</a:t>
+              <a:t>A primeira é a que fecha a venda. Segurança comove; risco jurídico faz a diretoria assinar.</a:t>
             </a:r>
             <a:endParaRPr lang="en-US" dirty="0"/>
           </a:p>
@@ -689,7 +690,7 @@
           <a:p>
             <a:r>
               <a:rPr lang="en-US" dirty="0"/>
-              <a:t/>
+              <a:t>Se perguntarem tamanho de mercado: dizer que o dado vem do Censo Escolar do INEP e que o preço praticado sai de conversa com escolas, e que nenhum dos dois foi estimado por nós.</a:t>
             </a:r>
             <a:endParaRPr lang="en-US" dirty="0"/>
           </a:p>
@@ -801,6 +802,94 @@
             <a:fld id="{F7021451-1387-4CA6-816F-3879F97B5CBC}" type="slidenum">
               <a:rPr lang="en-US"/>
               <a:t>12</a:t>
+            </a:fld>
+            <a:endParaRPr lang="en-US"/>
+          </a:p>
+        </p:txBody>
+      </p:sp>
+    </p:spTree>
+    <p:extLst>
+      <p:ext uri="{BB962C8B-B14F-4D97-AF65-F5344CB8AC3E}">
+        <p14:creationId xmlns:p14="http://schemas.microsoft.com/office/powerpoint/2010/main" val="1024086991"/>
+      </p:ext>
+    </p:extLst>
+  </p:cSld>
+  <p:clrMapOvr>
+    <a:masterClrMapping/>
+  </p:clrMapOvr>
+</p:notes>
+</file>
+
+<file path=ppt/notesSlides/notesSlide13.xml><?xml version="1.0" encoding="utf-8"?>
+<p:notes xmlns:a="http://schemas.openxmlformats.org/drawingml/2006/main" xmlns:r="http://schemas.openxmlformats.org/officeDocument/2006/relationships" xmlns:p="http://schemas.openxmlformats.org/presentationml/2006/main">
+  <p:cSld>
+    <p:spTree>
+      <p:nvGrpSpPr>
+        <p:cNvPr id="1" name=""/>
+        <p:cNvGrpSpPr/>
+        <p:nvPr/>
+      </p:nvGrpSpPr>
+      <p:grpSpPr>
+        <a:xfrm>
+          <a:off x="0" y="0"/>
+          <a:ext cx="0" cy="0"/>
+          <a:chOff x="0" y="0"/>
+          <a:chExt cx="0" cy="0"/>
+        </a:xfrm>
+      </p:grpSpPr>
+      <p:sp>
+        <p:nvSpPr>
+          <p:cNvPr id="2" name="Slide Image Placeholder 1"/>
+          <p:cNvSpPr>
+            <a:spLocks noGrp="1" noRot="1" noChangeAspect="1"/>
+          </p:cNvSpPr>
+          <p:nvPr>
+            <p:ph type="sldImg"/>
+          </p:nvPr>
+        </p:nvSpPr>
+        <p:spPr/>
+      </p:sp>
+      <p:sp>
+        <p:nvSpPr>
+          <p:cNvPr id="3" name="Notes Placeholder 2"/>
+          <p:cNvSpPr>
+            <a:spLocks noGrp="1"/>
+          </p:cNvSpPr>
+          <p:nvPr>
+            <p:ph type="body" idx="1"/>
+          </p:nvPr>
+        </p:nvSpPr>
+        <p:spPr/>
+        <p:txBody>
+          <a:bodyPr/>
+          <a:lstStyle/>
+          <a:p>
+            <a:r>
+              <a:rPr lang="en-US" dirty="0"/>
+              <a:t/>
+            </a:r>
+            <a:endParaRPr lang="en-US" dirty="0"/>
+          </a:p>
+        </p:txBody>
+      </p:sp>
+      <p:sp>
+        <p:nvSpPr>
+          <p:cNvPr id="4" name="Slide Number Placeholder 3"/>
+          <p:cNvSpPr>
+            <a:spLocks noGrp="1"/>
+          </p:cNvSpPr>
+          <p:nvPr>
+            <p:ph type="sldNum" sz="quarter" idx="10"/>
+          </p:nvPr>
+        </p:nvSpPr>
+        <p:spPr/>
+        <p:txBody>
+          <a:bodyPr/>
+          <a:lstStyle/>
+          <a:p>
+            <a:fld id="{F7021451-1387-4CA6-816F-3879F97B5CBC}" type="slidenum">
+              <a:rPr lang="en-US"/>
+              <a:t>13</a:t>
             </a:fld>
             <a:endParaRPr lang="en-US"/>
           </a:p>
@@ -2335,7 +2424,7 @@
                 <a:ea typeface="Courier New" pitchFamily="34" charset="-122"/>
                 <a:cs typeface="Courier New" pitchFamily="34" charset="-120"/>
               </a:rPr>
-              <a:t>VALOR ECONÔMICO E ENTRADA NO MERCADO</a:t>
+              <a:t>ONDE ESTÁ O VALOR PARA QUEM COMPRA</a:t>
             </a:r>
             <a:endParaRPr lang="en-US" sz="1100" dirty="0"/>
           </a:p>
@@ -2377,7 +2466,7 @@
                 <a:ea typeface="Arial" pitchFamily="34" charset="-122"/>
                 <a:cs typeface="Arial" pitchFamily="34" charset="-120"/>
               </a:rPr>
-              <a:t>O custo de cobrir mais</a:t>
+              <a:t>Três frentes, em ordem de</a:t>
             </a:r>
             <a:endParaRPr lang="en-US" sz="3600" dirty="0"/>
           </a:p>
@@ -2397,7 +2486,7 @@
                 <a:ea typeface="Arial" pitchFamily="34" charset="-122"/>
                 <a:cs typeface="Arial" pitchFamily="34" charset="-120"/>
               </a:rPr>
-              <a:t>uma sala é uma câmera.</a:t>
+              <a:t>força para uma escola.</a:t>
             </a:r>
             <a:endParaRPr lang="en-US" sz="3600" dirty="0"/>
           </a:p>
@@ -2405,609 +2494,22 @@
       </p:sp>
       <p:sp>
         <p:nvSpPr>
-          <p:cNvPr id="4" name="Text 2"/>
-          <p:cNvSpPr txBox="1"/>
-          <p:nvPr/>
-        </p:nvSpPr>
-        <p:spPr>
-          <a:xfrm>
-            <a:off x="685800" y="2514600"/>
-            <a:ext cx="10515600" cy="731520"/>
-          </a:xfrm>
-          <a:prstGeom prst="rect">
-            <a:avLst/>
-          </a:prstGeom>
-          <a:noFill/>
-          <a:ln/>
-        </p:spPr>
-        <p:txBody>
-          <a:bodyPr wrap="square" lIns="0" tIns="0" rIns="0" bIns="0" rtlCol="0" anchor="ctr"/>
-          <a:lstStyle/>
-          <a:p>
-            <a:pPr indent="0" marL="0">
-              <a:lnSpc>
-                <a:spcPts val="2200"/>
-              </a:lnSpc>
-              <a:buNone/>
-            </a:pPr>
-            <a:r>
-              <a:rPr lang="en-US" sz="1500" dirty="0">
-                <a:solidFill>
-                  <a:srgbClr val="9DB0A6"/>
-                </a:solidFill>
-                <a:latin typeface="Calibri" pitchFamily="34" charset="0"/>
-                <a:ea typeface="Calibri" pitchFamily="34" charset="-122"/>
-                <a:cs typeface="Calibri" pitchFamily="34" charset="-120"/>
-              </a:rPr>
-              <a:t>O concorrente cobra licença mensal POR CÂMERA, porque o vídeo dele roda na nuvem dele. O nosso roda na borda, e o que sobe para a nuvem é uma linha de texto.</a:t>
-            </a:r>
-            <a:endParaRPr lang="en-US" sz="1500" dirty="0"/>
-          </a:p>
-        </p:txBody>
-      </p:sp>
-      <p:sp>
-        <p:nvSpPr>
-          <p:cNvPr id="5" name="Text 3"/>
-          <p:cNvSpPr txBox="1"/>
-          <p:nvPr/>
-        </p:nvSpPr>
-        <p:spPr>
-          <a:xfrm>
-            <a:off x="685800" y="3246120"/>
-            <a:ext cx="5120640" cy="320040"/>
-          </a:xfrm>
-          <a:prstGeom prst="rect">
-            <a:avLst/>
-          </a:prstGeom>
-          <a:noFill/>
-          <a:ln/>
-        </p:spPr>
-        <p:txBody>
-          <a:bodyPr wrap="square" lIns="0" tIns="0" rIns="0" bIns="0" rtlCol="0" anchor="ctr"/>
-          <a:lstStyle/>
-          <a:p>
-            <a:pPr indent="0" marL="0">
-              <a:buNone/>
-            </a:pPr>
-            <a:r>
-              <a:rPr lang="en-US" sz="1800" b="1" dirty="0">
-                <a:solidFill>
-                  <a:srgbClr val="EDF3EF"/>
-                </a:solidFill>
-                <a:latin typeface="Arial" pitchFamily="34" charset="0"/>
-                <a:ea typeface="Arial" pitchFamily="34" charset="-122"/>
-                <a:cs typeface="Arial" pitchFamily="34" charset="-120"/>
-              </a:rPr>
-              <a:t>O que custa</a:t>
-            </a:r>
-            <a:endParaRPr lang="en-US" sz="1800" dirty="0"/>
-          </a:p>
-        </p:txBody>
-      </p:sp>
-      <p:sp>
-        <p:nvSpPr>
-          <p:cNvPr id="6" name="Shape 4"/>
+          <p:cNvPr id="4" name="Shape 2"/>
           <p:cNvSpPr/>
           <p:nvPr/>
         </p:nvSpPr>
         <p:spPr>
           <a:xfrm>
-            <a:off x="685800" y="3703320"/>
-            <a:ext cx="5120640" cy="0"/>
-          </a:xfrm>
-          <a:prstGeom prst="line">
-            <a:avLst/>
-          </a:prstGeom>
-          <a:noFill/>
-          <a:ln w="12700">
-            <a:solidFill>
-              <a:srgbClr val="24322B"/>
-            </a:solidFill>
-            <a:prstDash val="solid"/>
-          </a:ln>
-        </p:spPr>
-      </p:sp>
-      <p:sp>
-        <p:nvSpPr>
-          <p:cNvPr id="7" name="Text 5"/>
-          <p:cNvSpPr txBox="1"/>
-          <p:nvPr/>
-        </p:nvSpPr>
-        <p:spPr>
-          <a:xfrm>
-            <a:off x="685800" y="3785616"/>
-            <a:ext cx="3017520" cy="320040"/>
-          </a:xfrm>
-          <a:prstGeom prst="rect">
-            <a:avLst/>
-          </a:prstGeom>
-          <a:noFill/>
-          <a:ln/>
-        </p:spPr>
-        <p:txBody>
-          <a:bodyPr wrap="square" lIns="0" tIns="0" rIns="0" bIns="0" rtlCol="0" anchor="ctr"/>
-          <a:lstStyle/>
-          <a:p>
-            <a:pPr indent="0" marL="0">
-              <a:buNone/>
-            </a:pPr>
-            <a:r>
-              <a:rPr lang="en-US" sz="1300" b="1" dirty="0">
-                <a:solidFill>
-                  <a:srgbClr val="EDF3EF"/>
-                </a:solidFill>
-                <a:latin typeface="Arial" pitchFamily="34" charset="0"/>
-                <a:ea typeface="Arial" pitchFamily="34" charset="-122"/>
-                <a:cs typeface="Arial" pitchFamily="34" charset="-120"/>
-              </a:rPr>
-              <a:t>Câmera IP, por sala</a:t>
-            </a:r>
-            <a:endParaRPr lang="en-US" sz="1300" dirty="0"/>
-          </a:p>
-        </p:txBody>
-      </p:sp>
-      <p:sp>
-        <p:nvSpPr>
-          <p:cNvPr id="8" name="Text 6"/>
-          <p:cNvSpPr txBox="1"/>
-          <p:nvPr/>
-        </p:nvSpPr>
-        <p:spPr>
-          <a:xfrm>
-            <a:off x="3703320" y="3803904"/>
-            <a:ext cx="2103120" cy="292608"/>
-          </a:xfrm>
-          <a:prstGeom prst="rect">
-            <a:avLst/>
-          </a:prstGeom>
-          <a:noFill/>
-          <a:ln/>
-        </p:spPr>
-        <p:txBody>
-          <a:bodyPr wrap="square" lIns="0" tIns="0" rIns="0" bIns="0" rtlCol="0" anchor="ctr"/>
-          <a:lstStyle/>
-          <a:p>
-            <a:pPr algn="r" indent="0" marL="0">
-              <a:buNone/>
-            </a:pPr>
-            <a:r>
-              <a:rPr lang="en-US" sz="1100" dirty="0">
-                <a:solidFill>
-                  <a:srgbClr val="9DB0A6"/>
-                </a:solidFill>
-                <a:latin typeface="Courier New" pitchFamily="34" charset="0"/>
-                <a:ea typeface="Courier New" pitchFamily="34" charset="-122"/>
-                <a:cs typeface="Courier New" pitchFamily="34" charset="-120"/>
-              </a:rPr>
-              <a:t>R$ 200 a R$ 680</a:t>
-            </a:r>
-            <a:endParaRPr lang="en-US" sz="1100" dirty="0"/>
-          </a:p>
-        </p:txBody>
-      </p:sp>
-      <p:sp>
-        <p:nvSpPr>
-          <p:cNvPr id="9" name="Shape 7"/>
-          <p:cNvSpPr/>
-          <p:nvPr/>
-        </p:nvSpPr>
-        <p:spPr>
-          <a:xfrm>
-            <a:off x="685800" y="4178808"/>
-            <a:ext cx="5120640" cy="0"/>
-          </a:xfrm>
-          <a:prstGeom prst="line">
-            <a:avLst/>
-          </a:prstGeom>
-          <a:noFill/>
-          <a:ln w="12700">
-            <a:solidFill>
-              <a:srgbClr val="24322B"/>
-            </a:solidFill>
-            <a:prstDash val="solid"/>
-          </a:ln>
-        </p:spPr>
-      </p:sp>
-      <p:sp>
-        <p:nvSpPr>
-          <p:cNvPr id="10" name="Text 8"/>
-          <p:cNvSpPr txBox="1"/>
-          <p:nvPr/>
-        </p:nvSpPr>
-        <p:spPr>
-          <a:xfrm>
-            <a:off x="685800" y="4261104"/>
-            <a:ext cx="3017520" cy="320040"/>
-          </a:xfrm>
-          <a:prstGeom prst="rect">
-            <a:avLst/>
-          </a:prstGeom>
-          <a:noFill/>
-          <a:ln/>
-        </p:spPr>
-        <p:txBody>
-          <a:bodyPr wrap="square" lIns="0" tIns="0" rIns="0" bIns="0" rtlCol="0" anchor="ctr"/>
-          <a:lstStyle/>
-          <a:p>
-            <a:pPr indent="0" marL="0">
-              <a:buNone/>
-            </a:pPr>
-            <a:r>
-              <a:rPr lang="en-US" sz="1300" b="1" dirty="0">
-                <a:solidFill>
-                  <a:srgbClr val="EDF3EF"/>
-                </a:solidFill>
-                <a:latin typeface="Arial" pitchFamily="34" charset="0"/>
-                <a:ea typeface="Arial" pitchFamily="34" charset="-122"/>
-                <a:cs typeface="Arial" pitchFamily="34" charset="-120"/>
-              </a:rPr>
-              <a:t>Servidor</a:t>
-            </a:r>
-            <a:endParaRPr lang="en-US" sz="1300" dirty="0"/>
-          </a:p>
-        </p:txBody>
-      </p:sp>
-      <p:sp>
-        <p:nvSpPr>
-          <p:cNvPr id="11" name="Text 9"/>
-          <p:cNvSpPr txBox="1"/>
-          <p:nvPr/>
-        </p:nvSpPr>
-        <p:spPr>
-          <a:xfrm>
-            <a:off x="3703320" y="4279392"/>
-            <a:ext cx="2103120" cy="292608"/>
-          </a:xfrm>
-          <a:prstGeom prst="rect">
-            <a:avLst/>
-          </a:prstGeom>
-          <a:noFill/>
-          <a:ln/>
-        </p:spPr>
-        <p:txBody>
-          <a:bodyPr wrap="square" lIns="0" tIns="0" rIns="0" bIns="0" rtlCol="0" anchor="ctr"/>
-          <a:lstStyle/>
-          <a:p>
-            <a:pPr algn="r" indent="0" marL="0">
-              <a:buNone/>
-            </a:pPr>
-            <a:r>
-              <a:rPr lang="en-US" sz="1100" dirty="0">
-                <a:solidFill>
-                  <a:srgbClr val="9DB0A6"/>
-                </a:solidFill>
-                <a:latin typeface="Courier New" pitchFamily="34" charset="0"/>
-                <a:ea typeface="Courier New" pitchFamily="34" charset="-122"/>
-                <a:cs typeface="Courier New" pitchFamily="34" charset="-120"/>
-              </a:rPr>
-              <a:t>1 PC comum por escola</a:t>
-            </a:r>
-            <a:endParaRPr lang="en-US" sz="1100" dirty="0"/>
-          </a:p>
-        </p:txBody>
-      </p:sp>
-      <p:sp>
-        <p:nvSpPr>
-          <p:cNvPr id="12" name="Shape 10"/>
-          <p:cNvSpPr/>
-          <p:nvPr/>
-        </p:nvSpPr>
-        <p:spPr>
-          <a:xfrm>
-            <a:off x="685800" y="4654296"/>
-            <a:ext cx="5120640" cy="0"/>
-          </a:xfrm>
-          <a:prstGeom prst="line">
-            <a:avLst/>
-          </a:prstGeom>
-          <a:noFill/>
-          <a:ln w="12700">
-            <a:solidFill>
-              <a:srgbClr val="24322B"/>
-            </a:solidFill>
-            <a:prstDash val="solid"/>
-          </a:ln>
-        </p:spPr>
-      </p:sp>
-      <p:sp>
-        <p:nvSpPr>
-          <p:cNvPr id="13" name="Text 11"/>
-          <p:cNvSpPr txBox="1"/>
-          <p:nvPr/>
-        </p:nvSpPr>
-        <p:spPr>
-          <a:xfrm>
-            <a:off x="685800" y="4736592"/>
-            <a:ext cx="3017520" cy="320040"/>
-          </a:xfrm>
-          <a:prstGeom prst="rect">
-            <a:avLst/>
-          </a:prstGeom>
-          <a:noFill/>
-          <a:ln/>
-        </p:spPr>
-        <p:txBody>
-          <a:bodyPr wrap="square" lIns="0" tIns="0" rIns="0" bIns="0" rtlCol="0" anchor="ctr"/>
-          <a:lstStyle/>
-          <a:p>
-            <a:pPr indent="0" marL="0">
-              <a:buNone/>
-            </a:pPr>
-            <a:r>
-              <a:rPr lang="en-US" sz="1300" b="1" dirty="0">
-                <a:solidFill>
-                  <a:srgbClr val="EDF3EF"/>
-                </a:solidFill>
-                <a:latin typeface="Arial" pitchFamily="34" charset="0"/>
-                <a:ea typeface="Arial" pitchFamily="34" charset="-122"/>
-                <a:cs typeface="Arial" pitchFamily="34" charset="-120"/>
-              </a:rPr>
-              <a:t>Licença de software</a:t>
-            </a:r>
-            <a:endParaRPr lang="en-US" sz="1300" dirty="0"/>
-          </a:p>
-        </p:txBody>
-      </p:sp>
-      <p:sp>
-        <p:nvSpPr>
-          <p:cNvPr id="14" name="Text 12"/>
-          <p:cNvSpPr txBox="1"/>
-          <p:nvPr/>
-        </p:nvSpPr>
-        <p:spPr>
-          <a:xfrm>
-            <a:off x="3703320" y="4754880"/>
-            <a:ext cx="2103120" cy="292608"/>
-          </a:xfrm>
-          <a:prstGeom prst="rect">
-            <a:avLst/>
-          </a:prstGeom>
-          <a:noFill/>
-          <a:ln/>
-        </p:spPr>
-        <p:txBody>
-          <a:bodyPr wrap="square" lIns="0" tIns="0" rIns="0" bIns="0" rtlCol="0" anchor="ctr"/>
-          <a:lstStyle/>
-          <a:p>
-            <a:pPr algn="r" indent="0" marL="0">
-              <a:buNone/>
-            </a:pPr>
-            <a:r>
-              <a:rPr lang="en-US" sz="1100" dirty="0">
-                <a:solidFill>
-                  <a:srgbClr val="3FBF5A"/>
-                </a:solidFill>
-                <a:latin typeface="Courier New" pitchFamily="34" charset="0"/>
-                <a:ea typeface="Courier New" pitchFamily="34" charset="-122"/>
-                <a:cs typeface="Courier New" pitchFamily="34" charset="-120"/>
-              </a:rPr>
-              <a:t>R$ 0 por câmera</a:t>
-            </a:r>
-            <a:endParaRPr lang="en-US" sz="1100" dirty="0"/>
-          </a:p>
-        </p:txBody>
-      </p:sp>
-      <p:sp>
-        <p:nvSpPr>
-          <p:cNvPr id="15" name="Shape 13"/>
-          <p:cNvSpPr/>
-          <p:nvPr/>
-        </p:nvSpPr>
-        <p:spPr>
-          <a:xfrm>
-            <a:off x="685800" y="5129784"/>
-            <a:ext cx="5120640" cy="0"/>
-          </a:xfrm>
-          <a:prstGeom prst="line">
-            <a:avLst/>
-          </a:prstGeom>
-          <a:noFill/>
-          <a:ln w="12700">
-            <a:solidFill>
-              <a:srgbClr val="24322B"/>
-            </a:solidFill>
-            <a:prstDash val="solid"/>
-          </a:ln>
-        </p:spPr>
-      </p:sp>
-      <p:sp>
-        <p:nvSpPr>
-          <p:cNvPr id="16" name="Text 14"/>
-          <p:cNvSpPr txBox="1"/>
-          <p:nvPr/>
-        </p:nvSpPr>
-        <p:spPr>
-          <a:xfrm>
-            <a:off x="685800" y="5212080"/>
-            <a:ext cx="3017520" cy="320040"/>
-          </a:xfrm>
-          <a:prstGeom prst="rect">
-            <a:avLst/>
-          </a:prstGeom>
-          <a:noFill/>
-          <a:ln/>
-        </p:spPr>
-        <p:txBody>
-          <a:bodyPr wrap="square" lIns="0" tIns="0" rIns="0" bIns="0" rtlCol="0" anchor="ctr"/>
-          <a:lstStyle/>
-          <a:p>
-            <a:pPr indent="0" marL="0">
-              <a:buNone/>
-            </a:pPr>
-            <a:r>
-              <a:rPr lang="en-US" sz="1300" b="1" dirty="0">
-                <a:solidFill>
-                  <a:srgbClr val="EDF3EF"/>
-                </a:solidFill>
-                <a:latin typeface="Arial" pitchFamily="34" charset="0"/>
-                <a:ea typeface="Arial" pitchFamily="34" charset="-122"/>
-                <a:cs typeface="Arial" pitchFamily="34" charset="-120"/>
-              </a:rPr>
-              <a:t>Nuvem do alerta</a:t>
-            </a:r>
-            <a:endParaRPr lang="en-US" sz="1300" dirty="0"/>
-          </a:p>
-        </p:txBody>
-      </p:sp>
-      <p:sp>
-        <p:nvSpPr>
-          <p:cNvPr id="17" name="Text 15"/>
-          <p:cNvSpPr txBox="1"/>
-          <p:nvPr/>
-        </p:nvSpPr>
-        <p:spPr>
-          <a:xfrm>
-            <a:off x="3703320" y="5230368"/>
-            <a:ext cx="2103120" cy="292608"/>
-          </a:xfrm>
-          <a:prstGeom prst="rect">
-            <a:avLst/>
-          </a:prstGeom>
-          <a:noFill/>
-          <a:ln/>
-        </p:spPr>
-        <p:txBody>
-          <a:bodyPr wrap="square" lIns="0" tIns="0" rIns="0" bIns="0" rtlCol="0" anchor="ctr"/>
-          <a:lstStyle/>
-          <a:p>
-            <a:pPr algn="r" indent="0" marL="0">
-              <a:buNone/>
-            </a:pPr>
-            <a:r>
-              <a:rPr lang="en-US" sz="1100" dirty="0">
-                <a:solidFill>
-                  <a:srgbClr val="3FBF5A"/>
-                </a:solidFill>
-                <a:latin typeface="Courier New" pitchFamily="34" charset="0"/>
-                <a:ea typeface="Courier New" pitchFamily="34" charset="-122"/>
-                <a:cs typeface="Courier New" pitchFamily="34" charset="-120"/>
-              </a:rPr>
-              <a:t>centavos por mês</a:t>
-            </a:r>
-            <a:endParaRPr lang="en-US" sz="1100" dirty="0"/>
-          </a:p>
-        </p:txBody>
-      </p:sp>
-      <p:sp>
-        <p:nvSpPr>
-          <p:cNvPr id="18" name="Shape 16"/>
-          <p:cNvSpPr/>
-          <p:nvPr/>
-        </p:nvSpPr>
-        <p:spPr>
-          <a:xfrm>
-            <a:off x="685800" y="5605272"/>
-            <a:ext cx="5120640" cy="0"/>
-          </a:xfrm>
-          <a:prstGeom prst="line">
-            <a:avLst/>
-          </a:prstGeom>
-          <a:noFill/>
-          <a:ln w="12700">
-            <a:solidFill>
-              <a:srgbClr val="24322B"/>
-            </a:solidFill>
-            <a:prstDash val="solid"/>
-          </a:ln>
-        </p:spPr>
-      </p:sp>
-      <p:sp>
-        <p:nvSpPr>
-          <p:cNvPr id="19" name="Text 17"/>
-          <p:cNvSpPr txBox="1"/>
-          <p:nvPr/>
-        </p:nvSpPr>
-        <p:spPr>
-          <a:xfrm>
-            <a:off x="685800" y="5687568"/>
-            <a:ext cx="5120640" cy="365760"/>
-          </a:xfrm>
-          <a:prstGeom prst="rect">
-            <a:avLst/>
-          </a:prstGeom>
-          <a:noFill/>
-          <a:ln/>
-        </p:spPr>
-        <p:txBody>
-          <a:bodyPr wrap="square" lIns="0" tIns="0" rIns="0" bIns="0" rtlCol="0" anchor="ctr"/>
-          <a:lstStyle/>
-          <a:p>
-            <a:pPr indent="0" marL="0">
-              <a:lnSpc>
-                <a:spcPts val="1300"/>
-              </a:lnSpc>
-              <a:buNone/>
-            </a:pPr>
-            <a:r>
-              <a:rPr lang="en-US" sz="900" dirty="0">
-                <a:solidFill>
-                  <a:srgbClr val="6A7D74"/>
-                </a:solidFill>
-                <a:latin typeface="Courier New" pitchFamily="34" charset="0"/>
-                <a:ea typeface="Courier New" pitchFamily="34" charset="-122"/>
-                <a:cs typeface="Courier New" pitchFamily="34" charset="-120"/>
-              </a:rPr>
-              <a:t>sem placa de vídeo, sem custo por fluxo, sem mensalidade que cresce com a escola</a:t>
-            </a:r>
-            <a:endParaRPr lang="en-US" sz="900" dirty="0"/>
-          </a:p>
-        </p:txBody>
-      </p:sp>
-      <p:sp>
-        <p:nvSpPr>
-          <p:cNvPr id="20" name="Text 18"/>
-          <p:cNvSpPr txBox="1"/>
-          <p:nvPr/>
-        </p:nvSpPr>
-        <p:spPr>
-          <a:xfrm>
-            <a:off x="6492240" y="3246120"/>
-            <a:ext cx="5029200" cy="320040"/>
-          </a:xfrm>
-          <a:prstGeom prst="rect">
-            <a:avLst/>
-          </a:prstGeom>
-          <a:noFill/>
-          <a:ln/>
-        </p:spPr>
-        <p:txBody>
-          <a:bodyPr wrap="square" lIns="0" tIns="0" rIns="0" bIns="0" rtlCol="0" anchor="ctr"/>
-          <a:lstStyle/>
-          <a:p>
-            <a:pPr indent="0" marL="0">
-              <a:buNone/>
-            </a:pPr>
-            <a:r>
-              <a:rPr lang="en-US" sz="1800" b="1" dirty="0">
-                <a:solidFill>
-                  <a:srgbClr val="EDF3EF"/>
-                </a:solidFill>
-                <a:latin typeface="Arial" pitchFamily="34" charset="0"/>
-                <a:ea typeface="Arial" pitchFamily="34" charset="-122"/>
-                <a:cs typeface="Arial" pitchFamily="34" charset="-120"/>
-              </a:rPr>
-              <a:t>Como entra no mercado</a:t>
-            </a:r>
-            <a:endParaRPr lang="en-US" sz="1800" dirty="0"/>
-          </a:p>
-        </p:txBody>
-      </p:sp>
-      <p:sp>
-        <p:nvSpPr>
-          <p:cNvPr id="21" name="Shape 19"/>
-          <p:cNvSpPr/>
-          <p:nvPr/>
-        </p:nvSpPr>
-        <p:spPr>
-          <a:xfrm>
-            <a:off x="6492240" y="3721608"/>
-            <a:ext cx="292608" cy="292608"/>
-          </a:xfrm>
-          <a:prstGeom prst="ellipse">
-            <a:avLst/>
+            <a:off x="685800" y="3017520"/>
+            <a:ext cx="3410712" cy="2788920"/>
+          </a:xfrm>
+          <a:prstGeom prst="roundRect">
+            <a:avLst>
+              <a:gd name="adj" fmla="val 3279"/>
+            </a:avLst>
           </a:prstGeom>
           <a:solidFill>
-            <a:srgbClr val="0B100E"/>
+            <a:srgbClr val="17211C"/>
           </a:solidFill>
           <a:ln w="12700">
             <a:solidFill>
@@ -3019,30 +2521,30 @@
       </p:sp>
       <p:sp>
         <p:nvSpPr>
-          <p:cNvPr id="22" name="Text 20"/>
-          <p:cNvSpPr txBox="1"/>
-          <p:nvPr/>
-        </p:nvSpPr>
-        <p:spPr>
-          <a:xfrm>
-            <a:off x="6492240" y="3749040"/>
-            <a:ext cx="292608" cy="237744"/>
-          </a:xfrm>
-          <a:prstGeom prst="rect">
-            <a:avLst/>
-          </a:prstGeom>
-          <a:noFill/>
-          <a:ln/>
-        </p:spPr>
-        <p:txBody>
-          <a:bodyPr wrap="square" lIns="0" tIns="0" rIns="0" bIns="0" rtlCol="0" anchor="ctr"/>
-          <a:lstStyle/>
-          <a:p>
-            <a:pPr algn="ctr" indent="0" marL="0">
-              <a:buNone/>
-            </a:pPr>
-            <a:r>
-              <a:rPr lang="en-US" sz="1000" dirty="0">
+          <p:cNvPr id="5" name="Text 3"/>
+          <p:cNvSpPr txBox="1"/>
+          <p:nvPr/>
+        </p:nvSpPr>
+        <p:spPr>
+          <a:xfrm>
+            <a:off x="941832" y="3246120"/>
+            <a:ext cx="2926080" cy="228600"/>
+          </a:xfrm>
+          <a:prstGeom prst="rect">
+            <a:avLst/>
+          </a:prstGeom>
+          <a:noFill/>
+          <a:ln/>
+        </p:spPr>
+        <p:txBody>
+          <a:bodyPr wrap="square" lIns="0" tIns="0" rIns="0" bIns="0" rtlCol="0" anchor="ctr"/>
+          <a:lstStyle/>
+          <a:p>
+            <a:pPr indent="0" marL="0">
+              <a:buNone/>
+            </a:pPr>
+            <a:r>
+              <a:rPr lang="en-US" sz="950" spc="150" kern="0" dirty="0">
                 <a:solidFill>
                   <a:srgbClr val="3FBF5A"/>
                 </a:solidFill>
@@ -3050,38 +2552,41 @@
                 <a:ea typeface="Courier New" pitchFamily="34" charset="-122"/>
                 <a:cs typeface="Courier New" pitchFamily="34" charset="-120"/>
               </a:rPr>
-              <a:t>1</a:t>
-            </a:r>
-            <a:endParaRPr lang="en-US" sz="1000" dirty="0"/>
-          </a:p>
-        </p:txBody>
-      </p:sp>
-      <p:sp>
-        <p:nvSpPr>
-          <p:cNvPr id="23" name="Text 21"/>
-          <p:cNvSpPr txBox="1"/>
-          <p:nvPr/>
-        </p:nvSpPr>
-        <p:spPr>
-          <a:xfrm>
-            <a:off x="6949440" y="3703320"/>
-            <a:ext cx="4572000" cy="274320"/>
-          </a:xfrm>
-          <a:prstGeom prst="rect">
-            <a:avLst/>
-          </a:prstGeom>
-          <a:noFill/>
-          <a:ln/>
-        </p:spPr>
-        <p:txBody>
-          <a:bodyPr wrap="square" lIns="0" tIns="0" rIns="0" bIns="0" rtlCol="0" anchor="ctr"/>
-          <a:lstStyle/>
-          <a:p>
-            <a:pPr indent="0" marL="0">
-              <a:buNone/>
-            </a:pPr>
-            <a:r>
-              <a:rPr lang="en-US" sz="1400" b="1" dirty="0">
+              <a:t>O QUE FAZ ASSINAR</a:t>
+            </a:r>
+            <a:endParaRPr lang="en-US" sz="950" dirty="0"/>
+          </a:p>
+        </p:txBody>
+      </p:sp>
+      <p:sp>
+        <p:nvSpPr>
+          <p:cNvPr id="6" name="Text 4"/>
+          <p:cNvSpPr txBox="1"/>
+          <p:nvPr/>
+        </p:nvSpPr>
+        <p:spPr>
+          <a:xfrm>
+            <a:off x="941832" y="3520440"/>
+            <a:ext cx="2926080" cy="685800"/>
+          </a:xfrm>
+          <a:prstGeom prst="rect">
+            <a:avLst/>
+          </a:prstGeom>
+          <a:noFill/>
+          <a:ln/>
+        </p:spPr>
+        <p:txBody>
+          <a:bodyPr wrap="square" lIns="0" tIns="0" rIns="0" bIns="0" rtlCol="0" anchor="ctr"/>
+          <a:lstStyle/>
+          <a:p>
+            <a:pPr indent="0" marL="0">
+              <a:lnSpc>
+                <a:spcPts val="2100"/>
+              </a:lnSpc>
+              <a:buNone/>
+            </a:pPr>
+            <a:r>
+              <a:rPr lang="en-US" sz="1700" b="1" dirty="0">
                 <a:solidFill>
                   <a:srgbClr val="EDF3EF"/>
                 </a:solidFill>
@@ -3089,41 +2594,61 @@
                 <a:ea typeface="Arial" pitchFamily="34" charset="-122"/>
                 <a:cs typeface="Arial" pitchFamily="34" charset="-120"/>
               </a:rPr>
-              <a:t>Uma escola, de graça</a:t>
-            </a:r>
-            <a:endParaRPr lang="en-US" sz="1400" dirty="0"/>
-          </a:p>
-        </p:txBody>
-      </p:sp>
-      <p:sp>
-        <p:nvSpPr>
-          <p:cNvPr id="24" name="Text 22"/>
-          <p:cNvSpPr txBox="1"/>
-          <p:nvPr/>
-        </p:nvSpPr>
-        <p:spPr>
-          <a:xfrm>
-            <a:off x="6949440" y="3977640"/>
-            <a:ext cx="4572000" cy="502920"/>
-          </a:xfrm>
-          <a:prstGeom prst="rect">
-            <a:avLst/>
-          </a:prstGeom>
-          <a:noFill/>
-          <a:ln/>
-        </p:spPr>
-        <p:txBody>
-          <a:bodyPr wrap="square" lIns="0" tIns="0" rIns="0" bIns="0" rtlCol="0" anchor="ctr"/>
-          <a:lstStyle/>
+              <a:t>Risco jurídico,</a:t>
+            </a:r>
+            <a:endParaRPr lang="en-US" sz="1700" dirty="0"/>
+          </a:p>
           <a:p>
             <a:pPr indent="0" marL="0">
               <a:lnSpc>
-                <a:spcPts val="1400"/>
+                <a:spcPts val="2100"/>
               </a:lnSpc>
               <a:buNone/>
             </a:pPr>
             <a:r>
-              <a:rPr lang="en-US" sz="1150" dirty="0">
+              <a:rPr lang="en-US" sz="1700" b="1" dirty="0">
+                <a:solidFill>
+                  <a:srgbClr val="EDF3EF"/>
+                </a:solidFill>
+                <a:latin typeface="Arial" pitchFamily="34" charset="0"/>
+                <a:ea typeface="Arial" pitchFamily="34" charset="-122"/>
+                <a:cs typeface="Arial" pitchFamily="34" charset="-120"/>
+              </a:rPr>
+              <a:t>não segurança</a:t>
+            </a:r>
+            <a:endParaRPr lang="en-US" sz="1700" dirty="0"/>
+          </a:p>
+        </p:txBody>
+      </p:sp>
+      <p:sp>
+        <p:nvSpPr>
+          <p:cNvPr id="7" name="Text 5"/>
+          <p:cNvSpPr txBox="1"/>
+          <p:nvPr/>
+        </p:nvSpPr>
+        <p:spPr>
+          <a:xfrm>
+            <a:off x="941832" y="4279392"/>
+            <a:ext cx="2926080" cy="1234440"/>
+          </a:xfrm>
+          <a:prstGeom prst="rect">
+            <a:avLst/>
+          </a:prstGeom>
+          <a:noFill/>
+          <a:ln/>
+        </p:spPr>
+        <p:txBody>
+          <a:bodyPr wrap="square" lIns="0" tIns="0" rIns="0" bIns="0" rtlCol="0" anchor="ctr"/>
+          <a:lstStyle/>
+          <a:p>
+            <a:pPr indent="0" marL="0">
+              <a:lnSpc>
+                <a:spcPts val="1600"/>
+              </a:lnSpc>
+              <a:buNone/>
+            </a:pPr>
+            <a:r>
+              <a:rPr lang="en-US" sz="1200" dirty="0">
                 <a:solidFill>
                   <a:srgbClr val="9DB0A6"/>
                 </a:solidFill>
@@ -3131,28 +2656,69 @@
                 <a:ea typeface="Calibri" pitchFamily="34" charset="-122"/>
                 <a:cs typeface="Calibri" pitchFamily="34" charset="-120"/>
               </a:rPr>
-              <a:t>Em troca do dado que falta: quantos alertas por dia a coordenação aguenta, e quantos foram engano.</a:t>
-            </a:r>
-            <a:endParaRPr lang="en-US" sz="1150" dirty="0"/>
-          </a:p>
-        </p:txBody>
-      </p:sp>
-      <p:sp>
-        <p:nvSpPr>
-          <p:cNvPr id="25" name="Shape 23"/>
+              <a:t>O medo real de uma mantenedora não é perder uma queda. É o processo depois. Registro que denuncia adulteração, imagem com prazo, acesso rastreado e biometria com vencimento reduzem exposição.</a:t>
+            </a:r>
+            <a:endParaRPr lang="en-US" sz="1200" dirty="0"/>
+          </a:p>
+        </p:txBody>
+      </p:sp>
+      <p:sp>
+        <p:nvSpPr>
+          <p:cNvPr id="8" name="Text 6"/>
+          <p:cNvSpPr txBox="1"/>
+          <p:nvPr/>
+        </p:nvSpPr>
+        <p:spPr>
+          <a:xfrm>
+            <a:off x="941832" y="5440680"/>
+            <a:ext cx="2926080" cy="320040"/>
+          </a:xfrm>
+          <a:prstGeom prst="rect">
+            <a:avLst/>
+          </a:prstGeom>
+          <a:noFill/>
+          <a:ln/>
+        </p:spPr>
+        <p:txBody>
+          <a:bodyPr wrap="square" lIns="0" tIns="0" rIns="0" bIns="0" rtlCol="0" anchor="ctr"/>
+          <a:lstStyle/>
+          <a:p>
+            <a:pPr indent="0" marL="0">
+              <a:buNone/>
+            </a:pPr>
+            <a:r>
+              <a:rPr lang="en-US" sz="850" dirty="0">
+                <a:solidFill>
+                  <a:srgbClr val="6A7D74"/>
+                </a:solidFill>
+                <a:latin typeface="Courier New" pitchFamily="34" charset="0"/>
+                <a:ea typeface="Courier New" pitchFamily="34" charset="-122"/>
+                <a:cs typeface="Courier New" pitchFamily="34" charset="-120"/>
+              </a:rPr>
+              <a:t>LGPD, e a disputa judicial que vem depois</a:t>
+            </a:r>
+            <a:endParaRPr lang="en-US" sz="850" dirty="0"/>
+          </a:p>
+        </p:txBody>
+      </p:sp>
+      <p:sp>
+        <p:nvSpPr>
+          <p:cNvPr id="9" name="Shape 7"/>
           <p:cNvSpPr/>
           <p:nvPr/>
         </p:nvSpPr>
         <p:spPr>
           <a:xfrm>
-            <a:off x="6492240" y="4498848"/>
-            <a:ext cx="292608" cy="292608"/>
-          </a:xfrm>
-          <a:prstGeom prst="ellipse">
-            <a:avLst/>
+            <a:off x="4370832" y="3017520"/>
+            <a:ext cx="3410712" cy="2788920"/>
+          </a:xfrm>
+          <a:prstGeom prst="roundRect">
+            <a:avLst>
+              <a:gd name="adj" fmla="val 3279"/>
+            </a:avLst>
           </a:prstGeom>
           <a:solidFill>
-            <a:srgbClr val="0B100E"/>
+            <a:srgbClr val="17211C"/>
           </a:solidFill>
           <a:ln w="12700">
             <a:solidFill>
@@ -3164,30 +2730,30 @@
       </p:sp>
       <p:sp>
         <p:nvSpPr>
-          <p:cNvPr id="26" name="Text 24"/>
-          <p:cNvSpPr txBox="1"/>
-          <p:nvPr/>
-        </p:nvSpPr>
-        <p:spPr>
-          <a:xfrm>
-            <a:off x="6492240" y="4526280"/>
-            <a:ext cx="292608" cy="237744"/>
-          </a:xfrm>
-          <a:prstGeom prst="rect">
-            <a:avLst/>
-          </a:prstGeom>
-          <a:noFill/>
-          <a:ln/>
-        </p:spPr>
-        <p:txBody>
-          <a:bodyPr wrap="square" lIns="0" tIns="0" rIns="0" bIns="0" rtlCol="0" anchor="ctr"/>
-          <a:lstStyle/>
-          <a:p>
-            <a:pPr algn="ctr" indent="0" marL="0">
-              <a:buNone/>
-            </a:pPr>
-            <a:r>
-              <a:rPr lang="en-US" sz="1000" dirty="0">
+          <p:cNvPr id="10" name="Text 8"/>
+          <p:cNvSpPr txBox="1"/>
+          <p:nvPr/>
+        </p:nvSpPr>
+        <p:spPr>
+          <a:xfrm>
+            <a:off x="4626864" y="3246120"/>
+            <a:ext cx="2926080" cy="228600"/>
+          </a:xfrm>
+          <a:prstGeom prst="rect">
+            <a:avLst/>
+          </a:prstGeom>
+          <a:noFill/>
+          <a:ln/>
+        </p:spPr>
+        <p:txBody>
+          <a:bodyPr wrap="square" lIns="0" tIns="0" rIns="0" bIns="0" rtlCol="0" anchor="ctr"/>
+          <a:lstStyle/>
+          <a:p>
+            <a:pPr indent="0" marL="0">
+              <a:buNone/>
+            </a:pPr>
+            <a:r>
+              <a:rPr lang="en-US" sz="950" spc="150" kern="0" dirty="0">
                 <a:solidFill>
                   <a:srgbClr val="3FBF5A"/>
                 </a:solidFill>
@@ -3195,38 +2761,41 @@
                 <a:ea typeface="Courier New" pitchFamily="34" charset="-122"/>
                 <a:cs typeface="Courier New" pitchFamily="34" charset="-120"/>
               </a:rPr>
-              <a:t>2</a:t>
-            </a:r>
-            <a:endParaRPr lang="en-US" sz="1000" dirty="0"/>
-          </a:p>
-        </p:txBody>
-      </p:sp>
-      <p:sp>
-        <p:nvSpPr>
-          <p:cNvPr id="27" name="Text 25"/>
-          <p:cNvSpPr txBox="1"/>
-          <p:nvPr/>
-        </p:nvSpPr>
-        <p:spPr>
-          <a:xfrm>
-            <a:off x="6949440" y="4480560"/>
-            <a:ext cx="4572000" cy="274320"/>
-          </a:xfrm>
-          <a:prstGeom prst="rect">
-            <a:avLst/>
-          </a:prstGeom>
-          <a:noFill/>
-          <a:ln/>
-        </p:spPr>
-        <p:txBody>
-          <a:bodyPr wrap="square" lIns="0" tIns="0" rIns="0" bIns="0" rtlCol="0" anchor="ctr"/>
-          <a:lstStyle/>
-          <a:p>
-            <a:pPr indent="0" marL="0">
-              <a:buNone/>
-            </a:pPr>
-            <a:r>
-              <a:rPr lang="en-US" sz="1400" b="1" dirty="0">
+              <a:t>O QUE SALVA</a:t>
+            </a:r>
+            <a:endParaRPr lang="en-US" sz="950" dirty="0"/>
+          </a:p>
+        </p:txBody>
+      </p:sp>
+      <p:sp>
+        <p:nvSpPr>
+          <p:cNvPr id="11" name="Text 9"/>
+          <p:cNvSpPr txBox="1"/>
+          <p:nvPr/>
+        </p:nvSpPr>
+        <p:spPr>
+          <a:xfrm>
+            <a:off x="4626864" y="3520440"/>
+            <a:ext cx="2926080" cy="685800"/>
+          </a:xfrm>
+          <a:prstGeom prst="rect">
+            <a:avLst/>
+          </a:prstGeom>
+          <a:noFill/>
+          <a:ln/>
+        </p:spPr>
+        <p:txBody>
+          <a:bodyPr wrap="square" lIns="0" tIns="0" rIns="0" bIns="0" rtlCol="0" anchor="ctr"/>
+          <a:lstStyle/>
+          <a:p>
+            <a:pPr indent="0" marL="0">
+              <a:lnSpc>
+                <a:spcPts val="2100"/>
+              </a:lnSpc>
+              <a:buNone/>
+            </a:pPr>
+            <a:r>
+              <a:rPr lang="en-US" sz="1700" b="1" dirty="0">
                 <a:solidFill>
                   <a:srgbClr val="EDF3EF"/>
                 </a:solidFill>
@@ -3234,22 +2803,22 @@
                 <a:ea typeface="Arial" pitchFamily="34" charset="-122"/>
                 <a:cs typeface="Arial" pitchFamily="34" charset="-120"/>
               </a:rPr>
-              <a:t>O piloto vira carta</a:t>
-            </a:r>
-            <a:endParaRPr lang="en-US" sz="1400" dirty="0"/>
-          </a:p>
-        </p:txBody>
-      </p:sp>
-      <p:sp>
-        <p:nvSpPr>
-          <p:cNvPr id="28" name="Text 26"/>
-          <p:cNvSpPr txBox="1"/>
-          <p:nvPr/>
-        </p:nvSpPr>
-        <p:spPr>
-          <a:xfrm>
-            <a:off x="6949440" y="4754880"/>
-            <a:ext cx="4572000" cy="502920"/>
+              <a:t>Custo evitado</a:t>
+            </a:r>
+            <a:endParaRPr lang="en-US" sz="1700" dirty="0"/>
+          </a:p>
+        </p:txBody>
+      </p:sp>
+      <p:sp>
+        <p:nvSpPr>
+          <p:cNvPr id="12" name="Text 10"/>
+          <p:cNvSpPr txBox="1"/>
+          <p:nvPr/>
+        </p:nvSpPr>
+        <p:spPr>
+          <a:xfrm>
+            <a:off x="4626864" y="4279392"/>
+            <a:ext cx="2926080" cy="1234440"/>
           </a:xfrm>
           <a:prstGeom prst="rect">
             <a:avLst/>
@@ -3263,12 +2832,12 @@
           <a:p>
             <a:pPr indent="0" marL="0">
               <a:lnSpc>
-                <a:spcPts val="1400"/>
+                <a:spcPts val="1600"/>
               </a:lnSpc>
               <a:buNone/>
             </a:pPr>
             <a:r>
-              <a:rPr lang="en-US" sz="1150" dirty="0">
+              <a:rPr lang="en-US" sz="1200" dirty="0">
                 <a:solidFill>
                   <a:srgbClr val="9DB0A6"/>
                 </a:solidFill>
@@ -3276,28 +2845,69 @@
                 <a:ea typeface="Calibri" pitchFamily="34" charset="-122"/>
                 <a:cs typeface="Calibri" pitchFamily="34" charset="-120"/>
               </a:rPr>
-              <a:t>Um depoimento da coordenação abre a porta da segunda escola melhor que qualquer slide.</a:t>
-            </a:r>
-            <a:endParaRPr lang="en-US" sz="1150" dirty="0"/>
-          </a:p>
-        </p:txBody>
-      </p:sp>
-      <p:sp>
-        <p:nvSpPr>
-          <p:cNvPr id="29" name="Shape 27"/>
+              <a:t>Uma câmera comum só serve depois do fato. O valor está em chegar antes: socorro em segundos em vez de minutos, e uma queda vista no instante em que acontece.</a:t>
+            </a:r>
+            <a:endParaRPr lang="en-US" sz="1200" dirty="0"/>
+          </a:p>
+        </p:txBody>
+      </p:sp>
+      <p:sp>
+        <p:nvSpPr>
+          <p:cNvPr id="13" name="Text 11"/>
+          <p:cNvSpPr txBox="1"/>
+          <p:nvPr/>
+        </p:nvSpPr>
+        <p:spPr>
+          <a:xfrm>
+            <a:off x="4626864" y="5440680"/>
+            <a:ext cx="2926080" cy="320040"/>
+          </a:xfrm>
+          <a:prstGeom prst="rect">
+            <a:avLst/>
+          </a:prstGeom>
+          <a:noFill/>
+          <a:ln/>
+        </p:spPr>
+        <p:txBody>
+          <a:bodyPr wrap="square" lIns="0" tIns="0" rIns="0" bIns="0" rtlCol="0" anchor="ctr"/>
+          <a:lstStyle/>
+          <a:p>
+            <a:pPr indent="0" marL="0">
+              <a:buNone/>
+            </a:pPr>
+            <a:r>
+              <a:rPr lang="en-US" sz="850" dirty="0">
+                <a:solidFill>
+                  <a:srgbClr val="6A7D74"/>
+                </a:solidFill>
+                <a:latin typeface="Courier New" pitchFamily="34" charset="0"/>
+                <a:ea typeface="Courier New" pitchFamily="34" charset="-122"/>
+                <a:cs typeface="Courier New" pitchFamily="34" charset="-120"/>
+              </a:rPr>
+              <a:t>o alerta sai antes de alguém reclamar</a:t>
+            </a:r>
+            <a:endParaRPr lang="en-US" sz="850" dirty="0"/>
+          </a:p>
+        </p:txBody>
+      </p:sp>
+      <p:sp>
+        <p:nvSpPr>
+          <p:cNvPr id="14" name="Shape 12"/>
           <p:cNvSpPr/>
           <p:nvPr/>
         </p:nvSpPr>
         <p:spPr>
           <a:xfrm>
-            <a:off x="6492240" y="5276088"/>
-            <a:ext cx="292608" cy="292608"/>
-          </a:xfrm>
-          <a:prstGeom prst="ellipse">
-            <a:avLst/>
+            <a:off x="8055864" y="3017520"/>
+            <a:ext cx="3410712" cy="2788920"/>
+          </a:xfrm>
+          <a:prstGeom prst="roundRect">
+            <a:avLst>
+              <a:gd name="adj" fmla="val 3279"/>
+            </a:avLst>
           </a:prstGeom>
           <a:solidFill>
-            <a:srgbClr val="0B100E"/>
+            <a:srgbClr val="17211C"/>
           </a:solidFill>
           <a:ln w="12700">
             <a:solidFill>
@@ -3309,30 +2919,30 @@
       </p:sp>
       <p:sp>
         <p:nvSpPr>
-          <p:cNvPr id="30" name="Text 28"/>
-          <p:cNvSpPr txBox="1"/>
-          <p:nvPr/>
-        </p:nvSpPr>
-        <p:spPr>
-          <a:xfrm>
-            <a:off x="6492240" y="5303520"/>
-            <a:ext cx="292608" cy="237744"/>
-          </a:xfrm>
-          <a:prstGeom prst="rect">
-            <a:avLst/>
-          </a:prstGeom>
-          <a:noFill/>
-          <a:ln/>
-        </p:spPr>
-        <p:txBody>
-          <a:bodyPr wrap="square" lIns="0" tIns="0" rIns="0" bIns="0" rtlCol="0" anchor="ctr"/>
-          <a:lstStyle/>
-          <a:p>
-            <a:pPr algn="ctr" indent="0" marL="0">
-              <a:buNone/>
-            </a:pPr>
-            <a:r>
-              <a:rPr lang="en-US" sz="1000" dirty="0">
+          <p:cNvPr id="15" name="Text 13"/>
+          <p:cNvSpPr txBox="1"/>
+          <p:nvPr/>
+        </p:nvSpPr>
+        <p:spPr>
+          <a:xfrm>
+            <a:off x="8311896" y="3246120"/>
+            <a:ext cx="2926080" cy="228600"/>
+          </a:xfrm>
+          <a:prstGeom prst="rect">
+            <a:avLst/>
+          </a:prstGeom>
+          <a:noFill/>
+          <a:ln/>
+        </p:spPr>
+        <p:txBody>
+          <a:bodyPr wrap="square" lIns="0" tIns="0" rIns="0" bIns="0" rtlCol="0" anchor="ctr"/>
+          <a:lstStyle/>
+          <a:p>
+            <a:pPr indent="0" marL="0">
+              <a:buNone/>
+            </a:pPr>
+            <a:r>
+              <a:rPr lang="en-US" sz="950" spc="150" kern="0" dirty="0">
                 <a:solidFill>
                   <a:srgbClr val="3FBF5A"/>
                 </a:solidFill>
@@ -3340,38 +2950,41 @@
                 <a:ea typeface="Courier New" pitchFamily="34" charset="-122"/>
                 <a:cs typeface="Courier New" pitchFamily="34" charset="-120"/>
               </a:rPr>
-              <a:t>3</a:t>
-            </a:r>
-            <a:endParaRPr lang="en-US" sz="1000" dirty="0"/>
-          </a:p>
-        </p:txBody>
-      </p:sp>
-      <p:sp>
-        <p:nvSpPr>
-          <p:cNvPr id="31" name="Text 29"/>
-          <p:cNvSpPr txBox="1"/>
-          <p:nvPr/>
-        </p:nvSpPr>
-        <p:spPr>
-          <a:xfrm>
-            <a:off x="6949440" y="5257800"/>
-            <a:ext cx="4572000" cy="274320"/>
-          </a:xfrm>
-          <a:prstGeom prst="rect">
-            <a:avLst/>
-          </a:prstGeom>
-          <a:noFill/>
-          <a:ln/>
-        </p:spPr>
-        <p:txBody>
-          <a:bodyPr wrap="square" lIns="0" tIns="0" rIns="0" bIns="0" rtlCol="0" anchor="ctr"/>
-          <a:lstStyle/>
-          <a:p>
-            <a:pPr indent="0" marL="0">
-              <a:buNone/>
-            </a:pPr>
-            <a:r>
-              <a:rPr lang="en-US" sz="1400" b="1" dirty="0">
+              <a:t>O QUE SUBSTITUI</a:t>
+            </a:r>
+            <a:endParaRPr lang="en-US" sz="950" dirty="0"/>
+          </a:p>
+        </p:txBody>
+      </p:sp>
+      <p:sp>
+        <p:nvSpPr>
+          <p:cNvPr id="16" name="Text 14"/>
+          <p:cNvSpPr txBox="1"/>
+          <p:nvPr/>
+        </p:nvSpPr>
+        <p:spPr>
+          <a:xfrm>
+            <a:off x="8311896" y="3520440"/>
+            <a:ext cx="2926080" cy="685800"/>
+          </a:xfrm>
+          <a:prstGeom prst="rect">
+            <a:avLst/>
+          </a:prstGeom>
+          <a:noFill/>
+          <a:ln/>
+        </p:spPr>
+        <p:txBody>
+          <a:bodyPr wrap="square" lIns="0" tIns="0" rIns="0" bIns="0" rtlCol="0" anchor="ctr"/>
+          <a:lstStyle/>
+          <a:p>
+            <a:pPr indent="0" marL="0">
+              <a:lnSpc>
+                <a:spcPts val="2100"/>
+              </a:lnSpc>
+              <a:buNone/>
+            </a:pPr>
+            <a:r>
+              <a:rPr lang="en-US" sz="1700" b="1" dirty="0">
                 <a:solidFill>
                   <a:srgbClr val="EDF3EF"/>
                 </a:solidFill>
@@ -3379,22 +2992,22 @@
                 <a:ea typeface="Arial" pitchFamily="34" charset="-122"/>
                 <a:cs typeface="Arial" pitchFamily="34" charset="-120"/>
               </a:rPr>
-              <a:t>Vender para a rede</a:t>
-            </a:r>
-            <a:endParaRPr lang="en-US" sz="1400" dirty="0"/>
-          </a:p>
-        </p:txBody>
-      </p:sp>
-      <p:sp>
-        <p:nvSpPr>
-          <p:cNvPr id="32" name="Text 30"/>
-          <p:cNvSpPr txBox="1"/>
-          <p:nvPr/>
-        </p:nvSpPr>
-        <p:spPr>
-          <a:xfrm>
-            <a:off x="6949440" y="5532120"/>
-            <a:ext cx="4572000" cy="502920"/>
+              <a:t>Licença de nuvem</a:t>
+            </a:r>
+            <a:endParaRPr lang="en-US" sz="1700" dirty="0"/>
+          </a:p>
+        </p:txBody>
+      </p:sp>
+      <p:sp>
+        <p:nvSpPr>
+          <p:cNvPr id="17" name="Text 15"/>
+          <p:cNvSpPr txBox="1"/>
+          <p:nvPr/>
+        </p:nvSpPr>
+        <p:spPr>
+          <a:xfrm>
+            <a:off x="8311896" y="4279392"/>
+            <a:ext cx="2926080" cy="1234440"/>
           </a:xfrm>
           <a:prstGeom prst="rect">
             <a:avLst/>
@@ -3408,12 +3021,12 @@
           <a:p>
             <a:pPr indent="0" marL="0">
               <a:lnSpc>
-                <a:spcPts val="1400"/>
+                <a:spcPts val="1600"/>
               </a:lnSpc>
               <a:buNone/>
             </a:pPr>
             <a:r>
-              <a:rPr lang="en-US" sz="1150" dirty="0">
+              <a:rPr lang="en-US" sz="1200" dirty="0">
                 <a:solidFill>
                   <a:srgbClr val="9DB0A6"/>
                 </a:solidFill>
@@ -3421,41 +3034,38 @@
                 <a:ea typeface="Calibri" pitchFamily="34" charset="-122"/>
                 <a:cs typeface="Calibri" pitchFamily="34" charset="-120"/>
               </a:rPr>
-              <a:t>Grupo educacional tem dezenas de unidades e um decisor só. É para ele que custo marginal quase zero é irresistível.</a:t>
-            </a:r>
-            <a:endParaRPr lang="en-US" sz="1150" dirty="0"/>
-          </a:p>
-        </p:txBody>
-      </p:sp>
-      <p:sp>
-        <p:nvSpPr>
-          <p:cNvPr id="33" name="Text 31"/>
-          <p:cNvSpPr txBox="1"/>
-          <p:nvPr/>
-        </p:nvSpPr>
-        <p:spPr>
-          <a:xfrm>
-            <a:off x="6492240" y="5687568"/>
-            <a:ext cx="5029200" cy="365760"/>
-          </a:xfrm>
-          <a:prstGeom prst="rect">
-            <a:avLst/>
-          </a:prstGeom>
-          <a:noFill/>
-          <a:ln/>
-        </p:spPr>
-        <p:txBody>
-          <a:bodyPr wrap="square" lIns="0" tIns="0" rIns="0" bIns="0" rtlCol="0" anchor="ctr"/>
-          <a:lstStyle/>
-          <a:p>
-            <a:pPr indent="0" marL="0">
-              <a:lnSpc>
-                <a:spcPts val="1300"/>
-              </a:lnSpc>
-              <a:buNone/>
-            </a:pPr>
-            <a:r>
-              <a:rPr lang="en-US" sz="900" dirty="0">
+              <a:t>Se a escola já paga mensalidade por câmera para algum sistema de nuvem, o nosso número entra no lugar dele. E, ao contrário do dele, dá para conferir de onde sai.</a:t>
+            </a:r>
+            <a:endParaRPr lang="en-US" sz="1200" dirty="0"/>
+          </a:p>
+        </p:txBody>
+      </p:sp>
+      <p:sp>
+        <p:nvSpPr>
+          <p:cNvPr id="18" name="Text 16"/>
+          <p:cNvSpPr txBox="1"/>
+          <p:nvPr/>
+        </p:nvSpPr>
+        <p:spPr>
+          <a:xfrm>
+            <a:off x="8311896" y="5440680"/>
+            <a:ext cx="2926080" cy="320040"/>
+          </a:xfrm>
+          <a:prstGeom prst="rect">
+            <a:avLst/>
+          </a:prstGeom>
+          <a:noFill/>
+          <a:ln/>
+        </p:spPr>
+        <p:txBody>
+          <a:bodyPr wrap="square" lIns="0" tIns="0" rIns="0" bIns="0" rtlCol="0" anchor="ctr"/>
+          <a:lstStyle/>
+          <a:p>
+            <a:pPr indent="0" marL="0">
+              <a:buNone/>
+            </a:pPr>
+            <a:r>
+              <a:rPr lang="en-US" sz="850" dirty="0">
                 <a:solidFill>
                   <a:srgbClr val="6A7D74"/>
                 </a:solidFill>
@@ -3463,15 +3073,15 @@
                 <a:ea typeface="Courier New" pitchFamily="34" charset="-122"/>
                 <a:cs typeface="Courier New" pitchFamily="34" charset="-120"/>
               </a:rPr>
-              <a:t>Modelo: assinatura por escola, não por câmera. Expandir deixa de ser uma nova decisão de compra.</a:t>
-            </a:r>
-            <a:endParaRPr lang="en-US" sz="900" dirty="0"/>
-          </a:p>
-        </p:txBody>
-      </p:sp>
-      <p:sp>
-        <p:nvSpPr>
-          <p:cNvPr id="35" name="Text 32"/>
+              <a:t>comparável, e verificável linha a linha</a:t>
+            </a:r>
+            <a:endParaRPr lang="en-US" sz="850" dirty="0"/>
+          </a:p>
+        </p:txBody>
+      </p:sp>
+      <p:sp>
+        <p:nvSpPr>
+          <p:cNvPr id="20" name="Text 17"/>
           <p:cNvSpPr txBox="1"/>
           <p:nvPr/>
         </p:nvSpPr>
@@ -3510,7 +3120,7 @@
       </p:sp>
       <p:sp>
         <p:nvSpPr>
-          <p:cNvPr id="36" name="Text 33"/>
+          <p:cNvPr id="21" name="Text 18"/>
           <p:cNvSpPr txBox="1"/>
           <p:nvPr/>
         </p:nvSpPr>
@@ -3606,13 +3216,13 @@
             <a:r>
               <a:rPr lang="en-US" sz="1100" spc="200" kern="0" dirty="0">
                 <a:solidFill>
-                  <a:srgbClr val="E4572E"/>
+                  <a:srgbClr val="3FBF5A"/>
                 </a:solidFill>
                 <a:latin typeface="Courier New" pitchFamily="34" charset="0"/>
                 <a:ea typeface="Courier New" pitchFamily="34" charset="-122"/>
                 <a:cs typeface="Courier New" pitchFamily="34" charset="-120"/>
               </a:rPr>
-              <a:t>HONESTIDADE INTELECTUAL</a:t>
+              <a:t>VALOR ECONÔMICO E ENTRADA NO MERCADO</a:t>
             </a:r>
             <a:endParaRPr lang="en-US" sz="1100" dirty="0"/>
           </a:p>
@@ -3654,7 +3264,7 @@
                 <a:ea typeface="Arial" pitchFamily="34" charset="-122"/>
                 <a:cs typeface="Arial" pitchFamily="34" charset="-120"/>
               </a:rPr>
-              <a:t>O que ainda não medimos,</a:t>
+              <a:t>O custo de cobrir mais</a:t>
             </a:r>
             <a:endParaRPr lang="en-US" sz="3600" dirty="0"/>
           </a:p>
@@ -3674,7 +3284,7 @@
                 <a:ea typeface="Arial" pitchFamily="34" charset="-122"/>
                 <a:cs typeface="Arial" pitchFamily="34" charset="-120"/>
               </a:rPr>
-              <a:t>e não vamos inventar.</a:t>
+              <a:t>uma sala é uma câmera.</a:t>
             </a:r>
             <a:endParaRPr lang="en-US" sz="3600" dirty="0"/>
           </a:p>
@@ -3688,7 +3298,7 @@
         </p:nvSpPr>
         <p:spPr>
           <a:xfrm>
-            <a:off x="685800" y="2560320"/>
+            <a:off x="685800" y="2514600"/>
             <a:ext cx="10515600" cy="731520"/>
           </a:xfrm>
           <a:prstGeom prst="rect">
@@ -3716,7 +3326,7 @@
                 <a:ea typeface="Calibri" pitchFamily="34" charset="-122"/>
                 <a:cs typeface="Calibri" pitchFamily="34" charset="-120"/>
               </a:rPr>
-              <a:t>Três números que decidem se isto é negócio, e que nenhuma planilha nossa pode responder.</a:t>
+              <a:t>O concorrente cobra licença mensal POR CÂMERA, porque o vídeo dele roda na nuvem dele. O nosso roda na borda, e o que sobe para a nuvem é uma linha de texto.</a:t>
             </a:r>
             <a:endParaRPr lang="en-US" sz="1500" dirty="0"/>
           </a:p>
@@ -3724,19 +3334,564 @@
       </p:sp>
       <p:sp>
         <p:nvSpPr>
-          <p:cNvPr id="5" name="Shape 3"/>
+          <p:cNvPr id="5" name="Text 3"/>
+          <p:cNvSpPr txBox="1"/>
+          <p:nvPr/>
+        </p:nvSpPr>
+        <p:spPr>
+          <a:xfrm>
+            <a:off x="685800" y="3246120"/>
+            <a:ext cx="5120640" cy="320040"/>
+          </a:xfrm>
+          <a:prstGeom prst="rect">
+            <a:avLst/>
+          </a:prstGeom>
+          <a:noFill/>
+          <a:ln/>
+        </p:spPr>
+        <p:txBody>
+          <a:bodyPr wrap="square" lIns="0" tIns="0" rIns="0" bIns="0" rtlCol="0" anchor="ctr"/>
+          <a:lstStyle/>
+          <a:p>
+            <a:pPr indent="0" marL="0">
+              <a:buNone/>
+            </a:pPr>
+            <a:r>
+              <a:rPr lang="en-US" sz="1800" b="1" dirty="0">
+                <a:solidFill>
+                  <a:srgbClr val="EDF3EF"/>
+                </a:solidFill>
+                <a:latin typeface="Arial" pitchFamily="34" charset="0"/>
+                <a:ea typeface="Arial" pitchFamily="34" charset="-122"/>
+                <a:cs typeface="Arial" pitchFamily="34" charset="-120"/>
+              </a:rPr>
+              <a:t>O que custa</a:t>
+            </a:r>
+            <a:endParaRPr lang="en-US" sz="1800" dirty="0"/>
+          </a:p>
+        </p:txBody>
+      </p:sp>
+      <p:sp>
+        <p:nvSpPr>
+          <p:cNvPr id="6" name="Shape 4"/>
           <p:cNvSpPr/>
           <p:nvPr/>
         </p:nvSpPr>
         <p:spPr>
           <a:xfrm>
-            <a:off x="685800" y="3200400"/>
-            <a:ext cx="3410712" cy="1920240"/>
-          </a:xfrm>
-          <a:prstGeom prst="roundRect">
-            <a:avLst>
-              <a:gd name="adj" fmla="val 4762"/>
-            </a:avLst>
+            <a:off x="685800" y="3703320"/>
+            <a:ext cx="5120640" cy="0"/>
+          </a:xfrm>
+          <a:prstGeom prst="line">
+            <a:avLst/>
+          </a:prstGeom>
+          <a:noFill/>
+          <a:ln w="12700">
+            <a:solidFill>
+              <a:srgbClr val="24322B"/>
+            </a:solidFill>
+            <a:prstDash val="solid"/>
+          </a:ln>
+        </p:spPr>
+      </p:sp>
+      <p:sp>
+        <p:nvSpPr>
+          <p:cNvPr id="7" name="Text 5"/>
+          <p:cNvSpPr txBox="1"/>
+          <p:nvPr/>
+        </p:nvSpPr>
+        <p:spPr>
+          <a:xfrm>
+            <a:off x="685800" y="3785616"/>
+            <a:ext cx="3017520" cy="320040"/>
+          </a:xfrm>
+          <a:prstGeom prst="rect">
+            <a:avLst/>
+          </a:prstGeom>
+          <a:noFill/>
+          <a:ln/>
+        </p:spPr>
+        <p:txBody>
+          <a:bodyPr wrap="square" lIns="0" tIns="0" rIns="0" bIns="0" rtlCol="0" anchor="ctr"/>
+          <a:lstStyle/>
+          <a:p>
+            <a:pPr indent="0" marL="0">
+              <a:buNone/>
+            </a:pPr>
+            <a:r>
+              <a:rPr lang="en-US" sz="1300" b="1" dirty="0">
+                <a:solidFill>
+                  <a:srgbClr val="EDF3EF"/>
+                </a:solidFill>
+                <a:latin typeface="Arial" pitchFamily="34" charset="0"/>
+                <a:ea typeface="Arial" pitchFamily="34" charset="-122"/>
+                <a:cs typeface="Arial" pitchFamily="34" charset="-120"/>
+              </a:rPr>
+              <a:t>Câmera IP, por sala</a:t>
+            </a:r>
+            <a:endParaRPr lang="en-US" sz="1300" dirty="0"/>
+          </a:p>
+        </p:txBody>
+      </p:sp>
+      <p:sp>
+        <p:nvSpPr>
+          <p:cNvPr id="8" name="Text 6"/>
+          <p:cNvSpPr txBox="1"/>
+          <p:nvPr/>
+        </p:nvSpPr>
+        <p:spPr>
+          <a:xfrm>
+            <a:off x="3703320" y="3803904"/>
+            <a:ext cx="2103120" cy="292608"/>
+          </a:xfrm>
+          <a:prstGeom prst="rect">
+            <a:avLst/>
+          </a:prstGeom>
+          <a:noFill/>
+          <a:ln/>
+        </p:spPr>
+        <p:txBody>
+          <a:bodyPr wrap="square" lIns="0" tIns="0" rIns="0" bIns="0" rtlCol="0" anchor="ctr"/>
+          <a:lstStyle/>
+          <a:p>
+            <a:pPr algn="r" indent="0" marL="0">
+              <a:buNone/>
+            </a:pPr>
+            <a:r>
+              <a:rPr lang="en-US" sz="1100" dirty="0">
+                <a:solidFill>
+                  <a:srgbClr val="9DB0A6"/>
+                </a:solidFill>
+                <a:latin typeface="Courier New" pitchFamily="34" charset="0"/>
+                <a:ea typeface="Courier New" pitchFamily="34" charset="-122"/>
+                <a:cs typeface="Courier New" pitchFamily="34" charset="-120"/>
+              </a:rPr>
+              <a:t>R$ 200 a R$ 680</a:t>
+            </a:r>
+            <a:endParaRPr lang="en-US" sz="1100" dirty="0"/>
+          </a:p>
+        </p:txBody>
+      </p:sp>
+      <p:sp>
+        <p:nvSpPr>
+          <p:cNvPr id="9" name="Shape 7"/>
+          <p:cNvSpPr/>
+          <p:nvPr/>
+        </p:nvSpPr>
+        <p:spPr>
+          <a:xfrm>
+            <a:off x="685800" y="4178808"/>
+            <a:ext cx="5120640" cy="0"/>
+          </a:xfrm>
+          <a:prstGeom prst="line">
+            <a:avLst/>
+          </a:prstGeom>
+          <a:noFill/>
+          <a:ln w="12700">
+            <a:solidFill>
+              <a:srgbClr val="24322B"/>
+            </a:solidFill>
+            <a:prstDash val="solid"/>
+          </a:ln>
+        </p:spPr>
+      </p:sp>
+      <p:sp>
+        <p:nvSpPr>
+          <p:cNvPr id="10" name="Text 8"/>
+          <p:cNvSpPr txBox="1"/>
+          <p:nvPr/>
+        </p:nvSpPr>
+        <p:spPr>
+          <a:xfrm>
+            <a:off x="685800" y="4261104"/>
+            <a:ext cx="3017520" cy="320040"/>
+          </a:xfrm>
+          <a:prstGeom prst="rect">
+            <a:avLst/>
+          </a:prstGeom>
+          <a:noFill/>
+          <a:ln/>
+        </p:spPr>
+        <p:txBody>
+          <a:bodyPr wrap="square" lIns="0" tIns="0" rIns="0" bIns="0" rtlCol="0" anchor="ctr"/>
+          <a:lstStyle/>
+          <a:p>
+            <a:pPr indent="0" marL="0">
+              <a:buNone/>
+            </a:pPr>
+            <a:r>
+              <a:rPr lang="en-US" sz="1300" b="1" dirty="0">
+                <a:solidFill>
+                  <a:srgbClr val="EDF3EF"/>
+                </a:solidFill>
+                <a:latin typeface="Arial" pitchFamily="34" charset="0"/>
+                <a:ea typeface="Arial" pitchFamily="34" charset="-122"/>
+                <a:cs typeface="Arial" pitchFamily="34" charset="-120"/>
+              </a:rPr>
+              <a:t>Servidor</a:t>
+            </a:r>
+            <a:endParaRPr lang="en-US" sz="1300" dirty="0"/>
+          </a:p>
+        </p:txBody>
+      </p:sp>
+      <p:sp>
+        <p:nvSpPr>
+          <p:cNvPr id="11" name="Text 9"/>
+          <p:cNvSpPr txBox="1"/>
+          <p:nvPr/>
+        </p:nvSpPr>
+        <p:spPr>
+          <a:xfrm>
+            <a:off x="3703320" y="4279392"/>
+            <a:ext cx="2103120" cy="292608"/>
+          </a:xfrm>
+          <a:prstGeom prst="rect">
+            <a:avLst/>
+          </a:prstGeom>
+          <a:noFill/>
+          <a:ln/>
+        </p:spPr>
+        <p:txBody>
+          <a:bodyPr wrap="square" lIns="0" tIns="0" rIns="0" bIns="0" rtlCol="0" anchor="ctr"/>
+          <a:lstStyle/>
+          <a:p>
+            <a:pPr algn="r" indent="0" marL="0">
+              <a:buNone/>
+            </a:pPr>
+            <a:r>
+              <a:rPr lang="en-US" sz="1100" dirty="0">
+                <a:solidFill>
+                  <a:srgbClr val="9DB0A6"/>
+                </a:solidFill>
+                <a:latin typeface="Courier New" pitchFamily="34" charset="0"/>
+                <a:ea typeface="Courier New" pitchFamily="34" charset="-122"/>
+                <a:cs typeface="Courier New" pitchFamily="34" charset="-120"/>
+              </a:rPr>
+              <a:t>1 PC comum por escola</a:t>
+            </a:r>
+            <a:endParaRPr lang="en-US" sz="1100" dirty="0"/>
+          </a:p>
+        </p:txBody>
+      </p:sp>
+      <p:sp>
+        <p:nvSpPr>
+          <p:cNvPr id="12" name="Shape 10"/>
+          <p:cNvSpPr/>
+          <p:nvPr/>
+        </p:nvSpPr>
+        <p:spPr>
+          <a:xfrm>
+            <a:off x="685800" y="4654296"/>
+            <a:ext cx="5120640" cy="0"/>
+          </a:xfrm>
+          <a:prstGeom prst="line">
+            <a:avLst/>
+          </a:prstGeom>
+          <a:noFill/>
+          <a:ln w="12700">
+            <a:solidFill>
+              <a:srgbClr val="24322B"/>
+            </a:solidFill>
+            <a:prstDash val="solid"/>
+          </a:ln>
+        </p:spPr>
+      </p:sp>
+      <p:sp>
+        <p:nvSpPr>
+          <p:cNvPr id="13" name="Text 11"/>
+          <p:cNvSpPr txBox="1"/>
+          <p:nvPr/>
+        </p:nvSpPr>
+        <p:spPr>
+          <a:xfrm>
+            <a:off x="685800" y="4736592"/>
+            <a:ext cx="3017520" cy="320040"/>
+          </a:xfrm>
+          <a:prstGeom prst="rect">
+            <a:avLst/>
+          </a:prstGeom>
+          <a:noFill/>
+          <a:ln/>
+        </p:spPr>
+        <p:txBody>
+          <a:bodyPr wrap="square" lIns="0" tIns="0" rIns="0" bIns="0" rtlCol="0" anchor="ctr"/>
+          <a:lstStyle/>
+          <a:p>
+            <a:pPr indent="0" marL="0">
+              <a:buNone/>
+            </a:pPr>
+            <a:r>
+              <a:rPr lang="en-US" sz="1300" b="1" dirty="0">
+                <a:solidFill>
+                  <a:srgbClr val="EDF3EF"/>
+                </a:solidFill>
+                <a:latin typeface="Arial" pitchFamily="34" charset="0"/>
+                <a:ea typeface="Arial" pitchFamily="34" charset="-122"/>
+                <a:cs typeface="Arial" pitchFamily="34" charset="-120"/>
+              </a:rPr>
+              <a:t>Licença de software</a:t>
+            </a:r>
+            <a:endParaRPr lang="en-US" sz="1300" dirty="0"/>
+          </a:p>
+        </p:txBody>
+      </p:sp>
+      <p:sp>
+        <p:nvSpPr>
+          <p:cNvPr id="14" name="Text 12"/>
+          <p:cNvSpPr txBox="1"/>
+          <p:nvPr/>
+        </p:nvSpPr>
+        <p:spPr>
+          <a:xfrm>
+            <a:off x="3703320" y="4754880"/>
+            <a:ext cx="2103120" cy="292608"/>
+          </a:xfrm>
+          <a:prstGeom prst="rect">
+            <a:avLst/>
+          </a:prstGeom>
+          <a:noFill/>
+          <a:ln/>
+        </p:spPr>
+        <p:txBody>
+          <a:bodyPr wrap="square" lIns="0" tIns="0" rIns="0" bIns="0" rtlCol="0" anchor="ctr"/>
+          <a:lstStyle/>
+          <a:p>
+            <a:pPr algn="r" indent="0" marL="0">
+              <a:buNone/>
+            </a:pPr>
+            <a:r>
+              <a:rPr lang="en-US" sz="1100" dirty="0">
+                <a:solidFill>
+                  <a:srgbClr val="3FBF5A"/>
+                </a:solidFill>
+                <a:latin typeface="Courier New" pitchFamily="34" charset="0"/>
+                <a:ea typeface="Courier New" pitchFamily="34" charset="-122"/>
+                <a:cs typeface="Courier New" pitchFamily="34" charset="-120"/>
+              </a:rPr>
+              <a:t>R$ 0 por câmera</a:t>
+            </a:r>
+            <a:endParaRPr lang="en-US" sz="1100" dirty="0"/>
+          </a:p>
+        </p:txBody>
+      </p:sp>
+      <p:sp>
+        <p:nvSpPr>
+          <p:cNvPr id="15" name="Shape 13"/>
+          <p:cNvSpPr/>
+          <p:nvPr/>
+        </p:nvSpPr>
+        <p:spPr>
+          <a:xfrm>
+            <a:off x="685800" y="5129784"/>
+            <a:ext cx="5120640" cy="0"/>
+          </a:xfrm>
+          <a:prstGeom prst="line">
+            <a:avLst/>
+          </a:prstGeom>
+          <a:noFill/>
+          <a:ln w="12700">
+            <a:solidFill>
+              <a:srgbClr val="24322B"/>
+            </a:solidFill>
+            <a:prstDash val="solid"/>
+          </a:ln>
+        </p:spPr>
+      </p:sp>
+      <p:sp>
+        <p:nvSpPr>
+          <p:cNvPr id="16" name="Text 14"/>
+          <p:cNvSpPr txBox="1"/>
+          <p:nvPr/>
+        </p:nvSpPr>
+        <p:spPr>
+          <a:xfrm>
+            <a:off x="685800" y="5212080"/>
+            <a:ext cx="3017520" cy="320040"/>
+          </a:xfrm>
+          <a:prstGeom prst="rect">
+            <a:avLst/>
+          </a:prstGeom>
+          <a:noFill/>
+          <a:ln/>
+        </p:spPr>
+        <p:txBody>
+          <a:bodyPr wrap="square" lIns="0" tIns="0" rIns="0" bIns="0" rtlCol="0" anchor="ctr"/>
+          <a:lstStyle/>
+          <a:p>
+            <a:pPr indent="0" marL="0">
+              <a:buNone/>
+            </a:pPr>
+            <a:r>
+              <a:rPr lang="en-US" sz="1300" b="1" dirty="0">
+                <a:solidFill>
+                  <a:srgbClr val="EDF3EF"/>
+                </a:solidFill>
+                <a:latin typeface="Arial" pitchFamily="34" charset="0"/>
+                <a:ea typeface="Arial" pitchFamily="34" charset="-122"/>
+                <a:cs typeface="Arial" pitchFamily="34" charset="-120"/>
+              </a:rPr>
+              <a:t>Nuvem do alerta</a:t>
+            </a:r>
+            <a:endParaRPr lang="en-US" sz="1300" dirty="0"/>
+          </a:p>
+        </p:txBody>
+      </p:sp>
+      <p:sp>
+        <p:nvSpPr>
+          <p:cNvPr id="17" name="Text 15"/>
+          <p:cNvSpPr txBox="1"/>
+          <p:nvPr/>
+        </p:nvSpPr>
+        <p:spPr>
+          <a:xfrm>
+            <a:off x="3703320" y="5230368"/>
+            <a:ext cx="2103120" cy="292608"/>
+          </a:xfrm>
+          <a:prstGeom prst="rect">
+            <a:avLst/>
+          </a:prstGeom>
+          <a:noFill/>
+          <a:ln/>
+        </p:spPr>
+        <p:txBody>
+          <a:bodyPr wrap="square" lIns="0" tIns="0" rIns="0" bIns="0" rtlCol="0" anchor="ctr"/>
+          <a:lstStyle/>
+          <a:p>
+            <a:pPr algn="r" indent="0" marL="0">
+              <a:buNone/>
+            </a:pPr>
+            <a:r>
+              <a:rPr lang="en-US" sz="1100" dirty="0">
+                <a:solidFill>
+                  <a:srgbClr val="3FBF5A"/>
+                </a:solidFill>
+                <a:latin typeface="Courier New" pitchFamily="34" charset="0"/>
+                <a:ea typeface="Courier New" pitchFamily="34" charset="-122"/>
+                <a:cs typeface="Courier New" pitchFamily="34" charset="-120"/>
+              </a:rPr>
+              <a:t>centavos por mês</a:t>
+            </a:r>
+            <a:endParaRPr lang="en-US" sz="1100" dirty="0"/>
+          </a:p>
+        </p:txBody>
+      </p:sp>
+      <p:sp>
+        <p:nvSpPr>
+          <p:cNvPr id="18" name="Shape 16"/>
+          <p:cNvSpPr/>
+          <p:nvPr/>
+        </p:nvSpPr>
+        <p:spPr>
+          <a:xfrm>
+            <a:off x="685800" y="5605272"/>
+            <a:ext cx="5120640" cy="0"/>
+          </a:xfrm>
+          <a:prstGeom prst="line">
+            <a:avLst/>
+          </a:prstGeom>
+          <a:noFill/>
+          <a:ln w="12700">
+            <a:solidFill>
+              <a:srgbClr val="24322B"/>
+            </a:solidFill>
+            <a:prstDash val="solid"/>
+          </a:ln>
+        </p:spPr>
+      </p:sp>
+      <p:sp>
+        <p:nvSpPr>
+          <p:cNvPr id="19" name="Text 17"/>
+          <p:cNvSpPr txBox="1"/>
+          <p:nvPr/>
+        </p:nvSpPr>
+        <p:spPr>
+          <a:xfrm>
+            <a:off x="685800" y="5687568"/>
+            <a:ext cx="5120640" cy="365760"/>
+          </a:xfrm>
+          <a:prstGeom prst="rect">
+            <a:avLst/>
+          </a:prstGeom>
+          <a:noFill/>
+          <a:ln/>
+        </p:spPr>
+        <p:txBody>
+          <a:bodyPr wrap="square" lIns="0" tIns="0" rIns="0" bIns="0" rtlCol="0" anchor="ctr"/>
+          <a:lstStyle/>
+          <a:p>
+            <a:pPr indent="0" marL="0">
+              <a:lnSpc>
+                <a:spcPts val="1300"/>
+              </a:lnSpc>
+              <a:buNone/>
+            </a:pPr>
+            <a:r>
+              <a:rPr lang="en-US" sz="900" dirty="0">
+                <a:solidFill>
+                  <a:srgbClr val="6A7D74"/>
+                </a:solidFill>
+                <a:latin typeface="Courier New" pitchFamily="34" charset="0"/>
+                <a:ea typeface="Courier New" pitchFamily="34" charset="-122"/>
+                <a:cs typeface="Courier New" pitchFamily="34" charset="-120"/>
+              </a:rPr>
+              <a:t>sem placa de vídeo, sem custo por fluxo, sem mensalidade que cresce com a escola</a:t>
+            </a:r>
+            <a:endParaRPr lang="en-US" sz="900" dirty="0"/>
+          </a:p>
+        </p:txBody>
+      </p:sp>
+      <p:sp>
+        <p:nvSpPr>
+          <p:cNvPr id="20" name="Text 18"/>
+          <p:cNvSpPr txBox="1"/>
+          <p:nvPr/>
+        </p:nvSpPr>
+        <p:spPr>
+          <a:xfrm>
+            <a:off x="6492240" y="3246120"/>
+            <a:ext cx="5029200" cy="320040"/>
+          </a:xfrm>
+          <a:prstGeom prst="rect">
+            <a:avLst/>
+          </a:prstGeom>
+          <a:noFill/>
+          <a:ln/>
+        </p:spPr>
+        <p:txBody>
+          <a:bodyPr wrap="square" lIns="0" tIns="0" rIns="0" bIns="0" rtlCol="0" anchor="ctr"/>
+          <a:lstStyle/>
+          <a:p>
+            <a:pPr indent="0" marL="0">
+              <a:buNone/>
+            </a:pPr>
+            <a:r>
+              <a:rPr lang="en-US" sz="1800" b="1" dirty="0">
+                <a:solidFill>
+                  <a:srgbClr val="EDF3EF"/>
+                </a:solidFill>
+                <a:latin typeface="Arial" pitchFamily="34" charset="0"/>
+                <a:ea typeface="Arial" pitchFamily="34" charset="-122"/>
+                <a:cs typeface="Arial" pitchFamily="34" charset="-120"/>
+              </a:rPr>
+              <a:t>Como entra no mercado</a:t>
+            </a:r>
+            <a:endParaRPr lang="en-US" sz="1800" dirty="0"/>
+          </a:p>
+        </p:txBody>
+      </p:sp>
+      <p:sp>
+        <p:nvSpPr>
+          <p:cNvPr id="21" name="Shape 19"/>
+          <p:cNvSpPr/>
+          <p:nvPr/>
+        </p:nvSpPr>
+        <p:spPr>
+          <a:xfrm>
+            <a:off x="6492240" y="3721608"/>
+            <a:ext cx="292608" cy="292608"/>
+          </a:xfrm>
+          <a:prstGeom prst="ellipse">
+            <a:avLst/>
           </a:prstGeom>
           <a:solidFill>
             <a:srgbClr val="0B100E"/>
@@ -3745,39 +3900,75 @@
             <a:solidFill>
               <a:srgbClr val="24322B"/>
             </a:solidFill>
-            <a:prstDash val="dash"/>
+            <a:prstDash val="solid"/>
           </a:ln>
         </p:spPr>
       </p:sp>
       <p:sp>
         <p:nvSpPr>
-          <p:cNvPr id="6" name="Text 4"/>
-          <p:cNvSpPr txBox="1"/>
-          <p:nvPr/>
-        </p:nvSpPr>
-        <p:spPr>
-          <a:xfrm>
-            <a:off x="960120" y="3456432"/>
-            <a:ext cx="2880360" cy="548640"/>
-          </a:xfrm>
-          <a:prstGeom prst="rect">
-            <a:avLst/>
-          </a:prstGeom>
-          <a:noFill/>
-          <a:ln/>
-        </p:spPr>
-        <p:txBody>
-          <a:bodyPr wrap="square" lIns="0" tIns="0" rIns="0" bIns="0" rtlCol="0" anchor="ctr"/>
-          <a:lstStyle/>
-          <a:p>
-            <a:pPr indent="0" marL="0">
-              <a:lnSpc>
-                <a:spcPts val="1900"/>
-              </a:lnSpc>
-              <a:buNone/>
-            </a:pPr>
-            <a:r>
-              <a:rPr lang="en-US" sz="1500" b="1" dirty="0">
+          <p:cNvPr id="22" name="Text 20"/>
+          <p:cNvSpPr txBox="1"/>
+          <p:nvPr/>
+        </p:nvSpPr>
+        <p:spPr>
+          <a:xfrm>
+            <a:off x="6492240" y="3749040"/>
+            <a:ext cx="292608" cy="237744"/>
+          </a:xfrm>
+          <a:prstGeom prst="rect">
+            <a:avLst/>
+          </a:prstGeom>
+          <a:noFill/>
+          <a:ln/>
+        </p:spPr>
+        <p:txBody>
+          <a:bodyPr wrap="square" lIns="0" tIns="0" rIns="0" bIns="0" rtlCol="0" anchor="ctr"/>
+          <a:lstStyle/>
+          <a:p>
+            <a:pPr algn="ctr" indent="0" marL="0">
+              <a:buNone/>
+            </a:pPr>
+            <a:r>
+              <a:rPr lang="en-US" sz="1000" dirty="0">
+                <a:solidFill>
+                  <a:srgbClr val="3FBF5A"/>
+                </a:solidFill>
+                <a:latin typeface="Courier New" pitchFamily="34" charset="0"/>
+                <a:ea typeface="Courier New" pitchFamily="34" charset="-122"/>
+                <a:cs typeface="Courier New" pitchFamily="34" charset="-120"/>
+              </a:rPr>
+              <a:t>1</a:t>
+            </a:r>
+            <a:endParaRPr lang="en-US" sz="1000" dirty="0"/>
+          </a:p>
+        </p:txBody>
+      </p:sp>
+      <p:sp>
+        <p:nvSpPr>
+          <p:cNvPr id="23" name="Text 21"/>
+          <p:cNvSpPr txBox="1"/>
+          <p:nvPr/>
+        </p:nvSpPr>
+        <p:spPr>
+          <a:xfrm>
+            <a:off x="6949440" y="3703320"/>
+            <a:ext cx="4572000" cy="274320"/>
+          </a:xfrm>
+          <a:prstGeom prst="rect">
+            <a:avLst/>
+          </a:prstGeom>
+          <a:noFill/>
+          <a:ln/>
+        </p:spPr>
+        <p:txBody>
+          <a:bodyPr wrap="square" lIns="0" tIns="0" rIns="0" bIns="0" rtlCol="0" anchor="ctr"/>
+          <a:lstStyle/>
+          <a:p>
+            <a:pPr indent="0" marL="0">
+              <a:buNone/>
+            </a:pPr>
+            <a:r>
+              <a:rPr lang="en-US" sz="1400" b="1" dirty="0">
                 <a:solidFill>
                   <a:srgbClr val="EDF3EF"/>
                 </a:solidFill>
@@ -3785,38 +3976,41 @@
                 <a:ea typeface="Arial" pitchFamily="34" charset="-122"/>
                 <a:cs typeface="Arial" pitchFamily="34" charset="-120"/>
               </a:rPr>
-              <a:t>Quanto uma escola paga hoje</a:t>
-            </a:r>
-            <a:endParaRPr lang="en-US" sz="1500" dirty="0"/>
-          </a:p>
-        </p:txBody>
-      </p:sp>
-      <p:sp>
-        <p:nvSpPr>
-          <p:cNvPr id="7" name="Text 5"/>
-          <p:cNvSpPr txBox="1"/>
-          <p:nvPr/>
-        </p:nvSpPr>
-        <p:spPr>
-          <a:xfrm>
-            <a:off x="960120" y="4069080"/>
-            <a:ext cx="2880360" cy="320040"/>
-          </a:xfrm>
-          <a:prstGeom prst="rect">
-            <a:avLst/>
-          </a:prstGeom>
-          <a:noFill/>
-          <a:ln/>
-        </p:spPr>
-        <p:txBody>
-          <a:bodyPr wrap="square" lIns="0" tIns="0" rIns="0" bIns="0" rtlCol="0" anchor="ctr"/>
-          <a:lstStyle/>
-          <a:p>
-            <a:pPr indent="0" marL="0">
-              <a:buNone/>
-            </a:pPr>
-            <a:r>
-              <a:rPr lang="en-US" sz="1200" dirty="0">
+              <a:t>Uma escola, de graça</a:t>
+            </a:r>
+            <a:endParaRPr lang="en-US" sz="1400" dirty="0"/>
+          </a:p>
+        </p:txBody>
+      </p:sp>
+      <p:sp>
+        <p:nvSpPr>
+          <p:cNvPr id="24" name="Text 22"/>
+          <p:cNvSpPr txBox="1"/>
+          <p:nvPr/>
+        </p:nvSpPr>
+        <p:spPr>
+          <a:xfrm>
+            <a:off x="6949440" y="3977640"/>
+            <a:ext cx="4572000" cy="502920"/>
+          </a:xfrm>
+          <a:prstGeom prst="rect">
+            <a:avLst/>
+          </a:prstGeom>
+          <a:noFill/>
+          <a:ln/>
+        </p:spPr>
+        <p:txBody>
+          <a:bodyPr wrap="square" lIns="0" tIns="0" rIns="0" bIns="0" rtlCol="0" anchor="ctr"/>
+          <a:lstStyle/>
+          <a:p>
+            <a:pPr indent="0" marL="0">
+              <a:lnSpc>
+                <a:spcPts val="1400"/>
+              </a:lnSpc>
+              <a:buNone/>
+            </a:pPr>
+            <a:r>
+              <a:rPr lang="en-US" sz="1150" dirty="0">
                 <a:solidFill>
                   <a:srgbClr val="9DB0A6"/>
                 </a:solidFill>
@@ -3824,69 +4018,25 @@
                 <a:ea typeface="Calibri" pitchFamily="34" charset="-122"/>
                 <a:cs typeface="Calibri" pitchFamily="34" charset="-120"/>
               </a:rPr>
-              <a:t>por monitoramento eletrônico</a:t>
-            </a:r>
-            <a:endParaRPr lang="en-US" sz="1200" dirty="0"/>
-          </a:p>
-        </p:txBody>
-      </p:sp>
-      <p:sp>
-        <p:nvSpPr>
-          <p:cNvPr id="8" name="Text 6"/>
-          <p:cNvSpPr txBox="1"/>
-          <p:nvPr/>
-        </p:nvSpPr>
-        <p:spPr>
-          <a:xfrm>
-            <a:off x="960120" y="4526280"/>
-            <a:ext cx="2880360" cy="411480"/>
-          </a:xfrm>
-          <a:prstGeom prst="rect">
-            <a:avLst/>
-          </a:prstGeom>
-          <a:noFill/>
-          <a:ln/>
-        </p:spPr>
-        <p:txBody>
-          <a:bodyPr wrap="square" lIns="0" tIns="0" rIns="0" bIns="0" rtlCol="0" anchor="ctr"/>
-          <a:lstStyle/>
-          <a:p>
-            <a:pPr indent="0" marL="0">
-              <a:lnSpc>
-                <a:spcPts val="1200"/>
-              </a:lnSpc>
-              <a:buNone/>
-            </a:pPr>
-            <a:r>
-              <a:rPr lang="en-US" sz="900" dirty="0">
-                <a:solidFill>
-                  <a:srgbClr val="E4572E"/>
-                </a:solidFill>
-                <a:latin typeface="Courier New" pitchFamily="34" charset="0"/>
-                <a:ea typeface="Courier New" pitchFamily="34" charset="-122"/>
-                <a:cs typeface="Courier New" pitchFamily="34" charset="-120"/>
-              </a:rPr>
-              <a:t>fonte: ligar para três escolas</a:t>
-            </a:r>
-            <a:endParaRPr lang="en-US" sz="900" dirty="0"/>
-          </a:p>
-        </p:txBody>
-      </p:sp>
-      <p:sp>
-        <p:nvSpPr>
-          <p:cNvPr id="9" name="Shape 7"/>
+              <a:t>Em troca do dado que falta: quantos alertas por dia a coordenação aguenta, e quantos foram engano.</a:t>
+            </a:r>
+            <a:endParaRPr lang="en-US" sz="1150" dirty="0"/>
+          </a:p>
+        </p:txBody>
+      </p:sp>
+      <p:sp>
+        <p:nvSpPr>
+          <p:cNvPr id="25" name="Shape 23"/>
           <p:cNvSpPr/>
           <p:nvPr/>
         </p:nvSpPr>
         <p:spPr>
           <a:xfrm>
-            <a:off x="4370832" y="3200400"/>
-            <a:ext cx="3410712" cy="1920240"/>
-          </a:xfrm>
-          <a:prstGeom prst="roundRect">
-            <a:avLst>
-              <a:gd name="adj" fmla="val 4762"/>
-            </a:avLst>
+            <a:off x="6492240" y="4498848"/>
+            <a:ext cx="292608" cy="292608"/>
+          </a:xfrm>
+          <a:prstGeom prst="ellipse">
+            <a:avLst/>
           </a:prstGeom>
           <a:solidFill>
             <a:srgbClr val="0B100E"/>
@@ -3895,39 +4045,75 @@
             <a:solidFill>
               <a:srgbClr val="24322B"/>
             </a:solidFill>
-            <a:prstDash val="dash"/>
+            <a:prstDash val="solid"/>
           </a:ln>
         </p:spPr>
       </p:sp>
       <p:sp>
         <p:nvSpPr>
-          <p:cNvPr id="10" name="Text 8"/>
-          <p:cNvSpPr txBox="1"/>
-          <p:nvPr/>
-        </p:nvSpPr>
-        <p:spPr>
-          <a:xfrm>
-            <a:off x="4645152" y="3456432"/>
-            <a:ext cx="2880360" cy="548640"/>
-          </a:xfrm>
-          <a:prstGeom prst="rect">
-            <a:avLst/>
-          </a:prstGeom>
-          <a:noFill/>
-          <a:ln/>
-        </p:spPr>
-        <p:txBody>
-          <a:bodyPr wrap="square" lIns="0" tIns="0" rIns="0" bIns="0" rtlCol="0" anchor="ctr"/>
-          <a:lstStyle/>
-          <a:p>
-            <a:pPr indent="0" marL="0">
-              <a:lnSpc>
-                <a:spcPts val="1900"/>
-              </a:lnSpc>
-              <a:buNone/>
-            </a:pPr>
-            <a:r>
-              <a:rPr lang="en-US" sz="1500" b="1" dirty="0">
+          <p:cNvPr id="26" name="Text 24"/>
+          <p:cNvSpPr txBox="1"/>
+          <p:nvPr/>
+        </p:nvSpPr>
+        <p:spPr>
+          <a:xfrm>
+            <a:off x="6492240" y="4526280"/>
+            <a:ext cx="292608" cy="237744"/>
+          </a:xfrm>
+          <a:prstGeom prst="rect">
+            <a:avLst/>
+          </a:prstGeom>
+          <a:noFill/>
+          <a:ln/>
+        </p:spPr>
+        <p:txBody>
+          <a:bodyPr wrap="square" lIns="0" tIns="0" rIns="0" bIns="0" rtlCol="0" anchor="ctr"/>
+          <a:lstStyle/>
+          <a:p>
+            <a:pPr algn="ctr" indent="0" marL="0">
+              <a:buNone/>
+            </a:pPr>
+            <a:r>
+              <a:rPr lang="en-US" sz="1000" dirty="0">
+                <a:solidFill>
+                  <a:srgbClr val="3FBF5A"/>
+                </a:solidFill>
+                <a:latin typeface="Courier New" pitchFamily="34" charset="0"/>
+                <a:ea typeface="Courier New" pitchFamily="34" charset="-122"/>
+                <a:cs typeface="Courier New" pitchFamily="34" charset="-120"/>
+              </a:rPr>
+              <a:t>2</a:t>
+            </a:r>
+            <a:endParaRPr lang="en-US" sz="1000" dirty="0"/>
+          </a:p>
+        </p:txBody>
+      </p:sp>
+      <p:sp>
+        <p:nvSpPr>
+          <p:cNvPr id="27" name="Text 25"/>
+          <p:cNvSpPr txBox="1"/>
+          <p:nvPr/>
+        </p:nvSpPr>
+        <p:spPr>
+          <a:xfrm>
+            <a:off x="6949440" y="4480560"/>
+            <a:ext cx="4572000" cy="274320"/>
+          </a:xfrm>
+          <a:prstGeom prst="rect">
+            <a:avLst/>
+          </a:prstGeom>
+          <a:noFill/>
+          <a:ln/>
+        </p:spPr>
+        <p:txBody>
+          <a:bodyPr wrap="square" lIns="0" tIns="0" rIns="0" bIns="0" rtlCol="0" anchor="ctr"/>
+          <a:lstStyle/>
+          <a:p>
+            <a:pPr indent="0" marL="0">
+              <a:buNone/>
+            </a:pPr>
+            <a:r>
+              <a:rPr lang="en-US" sz="1400" b="1" dirty="0">
                 <a:solidFill>
                   <a:srgbClr val="EDF3EF"/>
                 </a:solidFill>
@@ -3935,38 +4121,41 @@
                 <a:ea typeface="Arial" pitchFamily="34" charset="-122"/>
                 <a:cs typeface="Arial" pitchFamily="34" charset="-120"/>
               </a:rPr>
-              <a:t>Quantas escolas no recorte</a:t>
-            </a:r>
-            <a:endParaRPr lang="en-US" sz="1500" dirty="0"/>
-          </a:p>
-        </p:txBody>
-      </p:sp>
-      <p:sp>
-        <p:nvSpPr>
-          <p:cNvPr id="11" name="Text 9"/>
-          <p:cNvSpPr txBox="1"/>
-          <p:nvPr/>
-        </p:nvSpPr>
-        <p:spPr>
-          <a:xfrm>
-            <a:off x="4645152" y="4069080"/>
-            <a:ext cx="2880360" cy="320040"/>
-          </a:xfrm>
-          <a:prstGeom prst="rect">
-            <a:avLst/>
-          </a:prstGeom>
-          <a:noFill/>
-          <a:ln/>
-        </p:spPr>
-        <p:txBody>
-          <a:bodyPr wrap="square" lIns="0" tIns="0" rIns="0" bIns="0" rtlCol="0" anchor="ctr"/>
-          <a:lstStyle/>
-          <a:p>
-            <a:pPr indent="0" marL="0">
-              <a:buNone/>
-            </a:pPr>
-            <a:r>
-              <a:rPr lang="en-US" sz="1200" dirty="0">
+              <a:t>O piloto vira carta</a:t>
+            </a:r>
+            <a:endParaRPr lang="en-US" sz="1400" dirty="0"/>
+          </a:p>
+        </p:txBody>
+      </p:sp>
+      <p:sp>
+        <p:nvSpPr>
+          <p:cNvPr id="28" name="Text 26"/>
+          <p:cNvSpPr txBox="1"/>
+          <p:nvPr/>
+        </p:nvSpPr>
+        <p:spPr>
+          <a:xfrm>
+            <a:off x="6949440" y="4754880"/>
+            <a:ext cx="4572000" cy="502920"/>
+          </a:xfrm>
+          <a:prstGeom prst="rect">
+            <a:avLst/>
+          </a:prstGeom>
+          <a:noFill/>
+          <a:ln/>
+        </p:spPr>
+        <p:txBody>
+          <a:bodyPr wrap="square" lIns="0" tIns="0" rIns="0" bIns="0" rtlCol="0" anchor="ctr"/>
+          <a:lstStyle/>
+          <a:p>
+            <a:pPr indent="0" marL="0">
+              <a:lnSpc>
+                <a:spcPts val="1400"/>
+              </a:lnSpc>
+              <a:buNone/>
+            </a:pPr>
+            <a:r>
+              <a:rPr lang="en-US" sz="1150" dirty="0">
                 <a:solidFill>
                   <a:srgbClr val="9DB0A6"/>
                 </a:solidFill>
@@ -3974,69 +4163,25 @@
                 <a:ea typeface="Calibri" pitchFamily="34" charset="-122"/>
                 <a:cs typeface="Calibri" pitchFamily="34" charset="-120"/>
               </a:rPr>
-              <a:t>rede, município ou grupo</a:t>
-            </a:r>
-            <a:endParaRPr lang="en-US" sz="1200" dirty="0"/>
-          </a:p>
-        </p:txBody>
-      </p:sp>
-      <p:sp>
-        <p:nvSpPr>
-          <p:cNvPr id="12" name="Text 10"/>
-          <p:cNvSpPr txBox="1"/>
-          <p:nvPr/>
-        </p:nvSpPr>
-        <p:spPr>
-          <a:xfrm>
-            <a:off x="4645152" y="4526280"/>
-            <a:ext cx="2880360" cy="411480"/>
-          </a:xfrm>
-          <a:prstGeom prst="rect">
-            <a:avLst/>
-          </a:prstGeom>
-          <a:noFill/>
-          <a:ln/>
-        </p:spPr>
-        <p:txBody>
-          <a:bodyPr wrap="square" lIns="0" tIns="0" rIns="0" bIns="0" rtlCol="0" anchor="ctr"/>
-          <a:lstStyle/>
-          <a:p>
-            <a:pPr indent="0" marL="0">
-              <a:lnSpc>
-                <a:spcPts val="1200"/>
-              </a:lnSpc>
-              <a:buNone/>
-            </a:pPr>
-            <a:r>
-              <a:rPr lang="en-US" sz="900" dirty="0">
-                <a:solidFill>
-                  <a:srgbClr val="E4572E"/>
-                </a:solidFill>
-                <a:latin typeface="Courier New" pitchFamily="34" charset="0"/>
-                <a:ea typeface="Courier New" pitchFamily="34" charset="-122"/>
-                <a:cs typeface="Courier New" pitchFamily="34" charset="-120"/>
-              </a:rPr>
-              <a:t>fonte: Censo Escolar, INEP</a:t>
-            </a:r>
-            <a:endParaRPr lang="en-US" sz="900" dirty="0"/>
-          </a:p>
-        </p:txBody>
-      </p:sp>
-      <p:sp>
-        <p:nvSpPr>
-          <p:cNvPr id="13" name="Shape 11"/>
+              <a:t>Um depoimento da coordenação abre a porta da segunda escola melhor que qualquer slide.</a:t>
+            </a:r>
+            <a:endParaRPr lang="en-US" sz="1150" dirty="0"/>
+          </a:p>
+        </p:txBody>
+      </p:sp>
+      <p:sp>
+        <p:nvSpPr>
+          <p:cNvPr id="29" name="Shape 27"/>
           <p:cNvSpPr/>
           <p:nvPr/>
         </p:nvSpPr>
         <p:spPr>
           <a:xfrm>
-            <a:off x="8055864" y="3200400"/>
-            <a:ext cx="3410712" cy="1920240"/>
-          </a:xfrm>
-          <a:prstGeom prst="roundRect">
-            <a:avLst>
-              <a:gd name="adj" fmla="val 4762"/>
-            </a:avLst>
+            <a:off x="6492240" y="5276088"/>
+            <a:ext cx="292608" cy="292608"/>
+          </a:xfrm>
+          <a:prstGeom prst="ellipse">
+            <a:avLst/>
           </a:prstGeom>
           <a:solidFill>
             <a:srgbClr val="0B100E"/>
@@ -4045,39 +4190,75 @@
             <a:solidFill>
               <a:srgbClr val="24322B"/>
             </a:solidFill>
-            <a:prstDash val="dash"/>
+            <a:prstDash val="solid"/>
           </a:ln>
         </p:spPr>
       </p:sp>
       <p:sp>
         <p:nvSpPr>
-          <p:cNvPr id="14" name="Text 12"/>
-          <p:cNvSpPr txBox="1"/>
-          <p:nvPr/>
-        </p:nvSpPr>
-        <p:spPr>
-          <a:xfrm>
-            <a:off x="8330184" y="3456432"/>
-            <a:ext cx="2880360" cy="548640"/>
-          </a:xfrm>
-          <a:prstGeom prst="rect">
-            <a:avLst/>
-          </a:prstGeom>
-          <a:noFill/>
-          <a:ln/>
-        </p:spPr>
-        <p:txBody>
-          <a:bodyPr wrap="square" lIns="0" tIns="0" rIns="0" bIns="0" rtlCol="0" anchor="ctr"/>
-          <a:lstStyle/>
-          <a:p>
-            <a:pPr indent="0" marL="0">
-              <a:lnSpc>
-                <a:spcPts val="1900"/>
-              </a:lnSpc>
-              <a:buNone/>
-            </a:pPr>
-            <a:r>
-              <a:rPr lang="en-US" sz="1500" b="1" dirty="0">
+          <p:cNvPr id="30" name="Text 28"/>
+          <p:cNvSpPr txBox="1"/>
+          <p:nvPr/>
+        </p:nvSpPr>
+        <p:spPr>
+          <a:xfrm>
+            <a:off x="6492240" y="5303520"/>
+            <a:ext cx="292608" cy="237744"/>
+          </a:xfrm>
+          <a:prstGeom prst="rect">
+            <a:avLst/>
+          </a:prstGeom>
+          <a:noFill/>
+          <a:ln/>
+        </p:spPr>
+        <p:txBody>
+          <a:bodyPr wrap="square" lIns="0" tIns="0" rIns="0" bIns="0" rtlCol="0" anchor="ctr"/>
+          <a:lstStyle/>
+          <a:p>
+            <a:pPr algn="ctr" indent="0" marL="0">
+              <a:buNone/>
+            </a:pPr>
+            <a:r>
+              <a:rPr lang="en-US" sz="1000" dirty="0">
+                <a:solidFill>
+                  <a:srgbClr val="3FBF5A"/>
+                </a:solidFill>
+                <a:latin typeface="Courier New" pitchFamily="34" charset="0"/>
+                <a:ea typeface="Courier New" pitchFamily="34" charset="-122"/>
+                <a:cs typeface="Courier New" pitchFamily="34" charset="-120"/>
+              </a:rPr>
+              <a:t>3</a:t>
+            </a:r>
+            <a:endParaRPr lang="en-US" sz="1000" dirty="0"/>
+          </a:p>
+        </p:txBody>
+      </p:sp>
+      <p:sp>
+        <p:nvSpPr>
+          <p:cNvPr id="31" name="Text 29"/>
+          <p:cNvSpPr txBox="1"/>
+          <p:nvPr/>
+        </p:nvSpPr>
+        <p:spPr>
+          <a:xfrm>
+            <a:off x="6949440" y="5257800"/>
+            <a:ext cx="4572000" cy="274320"/>
+          </a:xfrm>
+          <a:prstGeom prst="rect">
+            <a:avLst/>
+          </a:prstGeom>
+          <a:noFill/>
+          <a:ln/>
+        </p:spPr>
+        <p:txBody>
+          <a:bodyPr wrap="square" lIns="0" tIns="0" rIns="0" bIns="0" rtlCol="0" anchor="ctr"/>
+          <a:lstStyle/>
+          <a:p>
+            <a:pPr indent="0" marL="0">
+              <a:buNone/>
+            </a:pPr>
+            <a:r>
+              <a:rPr lang="en-US" sz="1400" b="1" dirty="0">
                 <a:solidFill>
                   <a:srgbClr val="EDF3EF"/>
                 </a:solidFill>
@@ -4085,38 +4266,41 @@
                 <a:ea typeface="Arial" pitchFamily="34" charset="-122"/>
                 <a:cs typeface="Arial" pitchFamily="34" charset="-120"/>
               </a:rPr>
-              <a:t>Alertas por dia que se aguenta</a:t>
-            </a:r>
-            <a:endParaRPr lang="en-US" sz="1500" dirty="0"/>
-          </a:p>
-        </p:txBody>
-      </p:sp>
-      <p:sp>
-        <p:nvSpPr>
-          <p:cNvPr id="15" name="Text 13"/>
-          <p:cNvSpPr txBox="1"/>
-          <p:nvPr/>
-        </p:nvSpPr>
-        <p:spPr>
-          <a:xfrm>
-            <a:off x="8330184" y="4069080"/>
-            <a:ext cx="2880360" cy="320040"/>
-          </a:xfrm>
-          <a:prstGeom prst="rect">
-            <a:avLst/>
-          </a:prstGeom>
-          <a:noFill/>
-          <a:ln/>
-        </p:spPr>
-        <p:txBody>
-          <a:bodyPr wrap="square" lIns="0" tIns="0" rIns="0" bIns="0" rtlCol="0" anchor="ctr"/>
-          <a:lstStyle/>
-          <a:p>
-            <a:pPr indent="0" marL="0">
-              <a:buNone/>
-            </a:pPr>
-            <a:r>
-              <a:rPr lang="en-US" sz="1200" dirty="0">
+              <a:t>Vender para a rede</a:t>
+            </a:r>
+            <a:endParaRPr lang="en-US" sz="1400" dirty="0"/>
+          </a:p>
+        </p:txBody>
+      </p:sp>
+      <p:sp>
+        <p:nvSpPr>
+          <p:cNvPr id="32" name="Text 30"/>
+          <p:cNvSpPr txBox="1"/>
+          <p:nvPr/>
+        </p:nvSpPr>
+        <p:spPr>
+          <a:xfrm>
+            <a:off x="6949440" y="5532120"/>
+            <a:ext cx="4572000" cy="502920"/>
+          </a:xfrm>
+          <a:prstGeom prst="rect">
+            <a:avLst/>
+          </a:prstGeom>
+          <a:noFill/>
+          <a:ln/>
+        </p:spPr>
+        <p:txBody>
+          <a:bodyPr wrap="square" lIns="0" tIns="0" rIns="0" bIns="0" rtlCol="0" anchor="ctr"/>
+          <a:lstStyle/>
+          <a:p>
+            <a:pPr indent="0" marL="0">
+              <a:lnSpc>
+                <a:spcPts val="1400"/>
+              </a:lnSpc>
+              <a:buNone/>
+            </a:pPr>
+            <a:r>
+              <a:rPr lang="en-US" sz="1150" dirty="0">
                 <a:solidFill>
                   <a:srgbClr val="9DB0A6"/>
                 </a:solidFill>
@@ -4124,22 +4308,22 @@
                 <a:ea typeface="Calibri" pitchFamily="34" charset="-122"/>
                 <a:cs typeface="Calibri" pitchFamily="34" charset="-120"/>
               </a:rPr>
-              <a:t>e quantos foram engano</a:t>
-            </a:r>
-            <a:endParaRPr lang="en-US" sz="1200" dirty="0"/>
-          </a:p>
-        </p:txBody>
-      </p:sp>
-      <p:sp>
-        <p:nvSpPr>
-          <p:cNvPr id="16" name="Text 14"/>
-          <p:cNvSpPr txBox="1"/>
-          <p:nvPr/>
-        </p:nvSpPr>
-        <p:spPr>
-          <a:xfrm>
-            <a:off x="8330184" y="4526280"/>
-            <a:ext cx="2880360" cy="411480"/>
+              <a:t>Grupo educacional tem dezenas de unidades e um decisor só. É para ele que custo marginal quase zero é irresistível.</a:t>
+            </a:r>
+            <a:endParaRPr lang="en-US" sz="1150" dirty="0"/>
+          </a:p>
+        </p:txBody>
+      </p:sp>
+      <p:sp>
+        <p:nvSpPr>
+          <p:cNvPr id="33" name="Text 31"/>
+          <p:cNvSpPr txBox="1"/>
+          <p:nvPr/>
+        </p:nvSpPr>
+        <p:spPr>
+          <a:xfrm>
+            <a:off x="6492240" y="5687568"/>
+            <a:ext cx="5029200" cy="365760"/>
           </a:xfrm>
           <a:prstGeom prst="rect">
             <a:avLst/>
@@ -4153,20 +4337,20 @@
           <a:p>
             <a:pPr indent="0" marL="0">
               <a:lnSpc>
-                <a:spcPts val="1200"/>
+                <a:spcPts val="1300"/>
               </a:lnSpc>
               <a:buNone/>
             </a:pPr>
             <a:r>
               <a:rPr lang="en-US" sz="900" dirty="0">
                 <a:solidFill>
-                  <a:srgbClr val="E4572E"/>
+                  <a:srgbClr val="6A7D74"/>
                 </a:solidFill>
                 <a:latin typeface="Courier New" pitchFamily="34" charset="0"/>
                 <a:ea typeface="Courier New" pitchFamily="34" charset="-122"/>
                 <a:cs typeface="Courier New" pitchFamily="34" charset="-120"/>
               </a:rPr>
-              <a:t>fonte: o piloto, e só ele</a:t>
+              <a:t>Modelo: assinatura por escola, não por câmera. Expandir deixa de ser uma nova decisão de compra.</a:t>
             </a:r>
             <a:endParaRPr lang="en-US" sz="900" dirty="0"/>
           </a:p>
@@ -4174,46 +4358,7 @@
       </p:sp>
       <p:sp>
         <p:nvSpPr>
-          <p:cNvPr id="17" name="Text 15"/>
-          <p:cNvSpPr txBox="1"/>
-          <p:nvPr/>
-        </p:nvSpPr>
-        <p:spPr>
-          <a:xfrm>
-            <a:off x="685800" y="5577840"/>
-            <a:ext cx="10515600" cy="411480"/>
-          </a:xfrm>
-          <a:prstGeom prst="rect">
-            <a:avLst/>
-          </a:prstGeom>
-          <a:noFill/>
-          <a:ln/>
-        </p:spPr>
-        <p:txBody>
-          <a:bodyPr wrap="square" lIns="0" tIns="0" rIns="0" bIns="0" rtlCol="0" anchor="ctr"/>
-          <a:lstStyle/>
-          <a:p>
-            <a:pPr indent="0" marL="0">
-              <a:buNone/>
-            </a:pPr>
-            <a:r>
-              <a:rPr lang="en-US" sz="1400" i="1" dirty="0">
-                <a:solidFill>
-                  <a:srgbClr val="9DB0A6"/>
-                </a:solidFill>
-                <a:latin typeface="Calibri" pitchFamily="34" charset="0"/>
-                <a:ea typeface="Calibri" pitchFamily="34" charset="-122"/>
-                <a:cs typeface="Calibri" pitchFamily="34" charset="-120"/>
-              </a:rPr>
-              <a:t>Uma banca pergunta a fonte. “Estimativa nossa” derruba o slide, e com ele o resto da apresentação.</a:t>
-            </a:r>
-            <a:endParaRPr lang="en-US" sz="1400" dirty="0"/>
-          </a:p>
-        </p:txBody>
-      </p:sp>
-      <p:sp>
-        <p:nvSpPr>
-          <p:cNvPr id="18" name="Text 16"/>
+          <p:cNvPr id="35" name="Text 32"/>
           <p:cNvSpPr txBox="1"/>
           <p:nvPr/>
         </p:nvSpPr>
@@ -4252,7 +4397,7 @@
       </p:sp>
       <p:sp>
         <p:nvSpPr>
-          <p:cNvPr id="19" name="Text 17"/>
+          <p:cNvPr id="36" name="Text 33"/>
           <p:cNvSpPr txBox="1"/>
           <p:nvPr/>
         </p:nvSpPr>
@@ -4300,6 +4445,748 @@
 <file path=ppt/slides/slide12.xml><?xml version="1.0" encoding="utf-8"?>
 <p:sld xmlns:a="http://schemas.openxmlformats.org/drawingml/2006/main" xmlns:r="http://schemas.openxmlformats.org/officeDocument/2006/relationships" xmlns:p="http://schemas.openxmlformats.org/presentationml/2006/main">
   <p:cSld name="Slide 12">
+    <p:bg>
+      <p:bgPr>
+        <a:solidFill>
+          <a:srgbClr val="0B100E"/>
+        </a:solidFill>
+      </p:bgPr>
+    </p:bg>
+    <p:spTree>
+      <p:nvGrpSpPr>
+        <p:cNvPr id="1" name=""/>
+        <p:cNvGrpSpPr/>
+        <p:nvPr/>
+      </p:nvGrpSpPr>
+      <p:grpSpPr>
+        <a:xfrm>
+          <a:off x="0" y="0"/>
+          <a:ext cx="0" cy="0"/>
+          <a:chOff x="0" y="0"/>
+          <a:chExt cx="0" cy="0"/>
+        </a:xfrm>
+      </p:grpSpPr>
+      <p:sp>
+        <p:nvSpPr>
+          <p:cNvPr id="2" name="Text 0"/>
+          <p:cNvSpPr txBox="1"/>
+          <p:nvPr/>
+        </p:nvSpPr>
+        <p:spPr>
+          <a:xfrm>
+            <a:off x="685800" y="384048"/>
+            <a:ext cx="10820095" cy="274320"/>
+          </a:xfrm>
+          <a:prstGeom prst="rect">
+            <a:avLst/>
+          </a:prstGeom>
+          <a:noFill/>
+          <a:ln/>
+        </p:spPr>
+        <p:txBody>
+          <a:bodyPr wrap="square" lIns="0" tIns="0" rIns="0" bIns="0" rtlCol="0" anchor="ctr"/>
+          <a:lstStyle/>
+          <a:p>
+            <a:pPr indent="0" marL="0">
+              <a:buNone/>
+            </a:pPr>
+            <a:r>
+              <a:rPr lang="en-US" sz="1100" spc="200" kern="0" dirty="0">
+                <a:solidFill>
+                  <a:srgbClr val="E4572E"/>
+                </a:solidFill>
+                <a:latin typeface="Courier New" pitchFamily="34" charset="0"/>
+                <a:ea typeface="Courier New" pitchFamily="34" charset="-122"/>
+                <a:cs typeface="Courier New" pitchFamily="34" charset="-120"/>
+              </a:rPr>
+              <a:t>HONESTIDADE INTELECTUAL</a:t>
+            </a:r>
+            <a:endParaRPr lang="en-US" sz="1100" dirty="0"/>
+          </a:p>
+        </p:txBody>
+      </p:sp>
+      <p:sp>
+        <p:nvSpPr>
+          <p:cNvPr id="3" name="Text 1"/>
+          <p:cNvSpPr txBox="1"/>
+          <p:nvPr/>
+        </p:nvSpPr>
+        <p:spPr>
+          <a:xfrm>
+            <a:off x="685800" y="749808"/>
+            <a:ext cx="10820095" cy="1417320"/>
+          </a:xfrm>
+          <a:prstGeom prst="rect">
+            <a:avLst/>
+          </a:prstGeom>
+          <a:noFill/>
+          <a:ln/>
+        </p:spPr>
+        <p:txBody>
+          <a:bodyPr wrap="square" lIns="0" tIns="0" rIns="0" bIns="0" rtlCol="0" anchor="ctr"/>
+          <a:lstStyle/>
+          <a:p>
+            <a:pPr indent="0" marL="0">
+              <a:lnSpc>
+                <a:spcPts val="3800"/>
+              </a:lnSpc>
+              <a:buNone/>
+            </a:pPr>
+            <a:r>
+              <a:rPr lang="en-US" sz="3600" b="1" dirty="0">
+                <a:solidFill>
+                  <a:srgbClr val="EDF3EF"/>
+                </a:solidFill>
+                <a:latin typeface="Arial" pitchFamily="34" charset="0"/>
+                <a:ea typeface="Arial" pitchFamily="34" charset="-122"/>
+                <a:cs typeface="Arial" pitchFamily="34" charset="-120"/>
+              </a:rPr>
+              <a:t>O que ainda não medimos,</a:t>
+            </a:r>
+            <a:endParaRPr lang="en-US" sz="3600" dirty="0"/>
+          </a:p>
+          <a:p>
+            <a:pPr indent="0" marL="0">
+              <a:lnSpc>
+                <a:spcPts val="3800"/>
+              </a:lnSpc>
+              <a:buNone/>
+            </a:pPr>
+            <a:r>
+              <a:rPr lang="en-US" sz="3600" b="1" dirty="0">
+                <a:solidFill>
+                  <a:srgbClr val="EDF3EF"/>
+                </a:solidFill>
+                <a:latin typeface="Arial" pitchFamily="34" charset="0"/>
+                <a:ea typeface="Arial" pitchFamily="34" charset="-122"/>
+                <a:cs typeface="Arial" pitchFamily="34" charset="-120"/>
+              </a:rPr>
+              <a:t>e não vamos inventar.</a:t>
+            </a:r>
+            <a:endParaRPr lang="en-US" sz="3600" dirty="0"/>
+          </a:p>
+        </p:txBody>
+      </p:sp>
+      <p:sp>
+        <p:nvSpPr>
+          <p:cNvPr id="4" name="Text 2"/>
+          <p:cNvSpPr txBox="1"/>
+          <p:nvPr/>
+        </p:nvSpPr>
+        <p:spPr>
+          <a:xfrm>
+            <a:off x="685800" y="2560320"/>
+            <a:ext cx="10515600" cy="731520"/>
+          </a:xfrm>
+          <a:prstGeom prst="rect">
+            <a:avLst/>
+          </a:prstGeom>
+          <a:noFill/>
+          <a:ln/>
+        </p:spPr>
+        <p:txBody>
+          <a:bodyPr wrap="square" lIns="0" tIns="0" rIns="0" bIns="0" rtlCol="0" anchor="ctr"/>
+          <a:lstStyle/>
+          <a:p>
+            <a:pPr indent="0" marL="0">
+              <a:lnSpc>
+                <a:spcPts val="2200"/>
+              </a:lnSpc>
+              <a:buNone/>
+            </a:pPr>
+            <a:r>
+              <a:rPr lang="en-US" sz="1500" dirty="0">
+                <a:solidFill>
+                  <a:srgbClr val="9DB0A6"/>
+                </a:solidFill>
+                <a:latin typeface="Calibri" pitchFamily="34" charset="0"/>
+                <a:ea typeface="Calibri" pitchFamily="34" charset="-122"/>
+                <a:cs typeface="Calibri" pitchFamily="34" charset="-120"/>
+              </a:rPr>
+              <a:t>Três números que decidem se isto é negócio, e que nenhuma planilha nossa pode responder.</a:t>
+            </a:r>
+            <a:endParaRPr lang="en-US" sz="1500" dirty="0"/>
+          </a:p>
+        </p:txBody>
+      </p:sp>
+      <p:sp>
+        <p:nvSpPr>
+          <p:cNvPr id="5" name="Shape 3"/>
+          <p:cNvSpPr/>
+          <p:nvPr/>
+        </p:nvSpPr>
+        <p:spPr>
+          <a:xfrm>
+            <a:off x="685800" y="3200400"/>
+            <a:ext cx="3410712" cy="1920240"/>
+          </a:xfrm>
+          <a:prstGeom prst="roundRect">
+            <a:avLst>
+              <a:gd name="adj" fmla="val 4762"/>
+            </a:avLst>
+          </a:prstGeom>
+          <a:solidFill>
+            <a:srgbClr val="0B100E"/>
+          </a:solidFill>
+          <a:ln w="12700">
+            <a:solidFill>
+              <a:srgbClr val="24322B"/>
+            </a:solidFill>
+            <a:prstDash val="dash"/>
+          </a:ln>
+        </p:spPr>
+      </p:sp>
+      <p:sp>
+        <p:nvSpPr>
+          <p:cNvPr id="6" name="Text 4"/>
+          <p:cNvSpPr txBox="1"/>
+          <p:nvPr/>
+        </p:nvSpPr>
+        <p:spPr>
+          <a:xfrm>
+            <a:off x="960120" y="3456432"/>
+            <a:ext cx="2880360" cy="548640"/>
+          </a:xfrm>
+          <a:prstGeom prst="rect">
+            <a:avLst/>
+          </a:prstGeom>
+          <a:noFill/>
+          <a:ln/>
+        </p:spPr>
+        <p:txBody>
+          <a:bodyPr wrap="square" lIns="0" tIns="0" rIns="0" bIns="0" rtlCol="0" anchor="ctr"/>
+          <a:lstStyle/>
+          <a:p>
+            <a:pPr indent="0" marL="0">
+              <a:lnSpc>
+                <a:spcPts val="1900"/>
+              </a:lnSpc>
+              <a:buNone/>
+            </a:pPr>
+            <a:r>
+              <a:rPr lang="en-US" sz="1500" b="1" dirty="0">
+                <a:solidFill>
+                  <a:srgbClr val="EDF3EF"/>
+                </a:solidFill>
+                <a:latin typeface="Arial" pitchFamily="34" charset="0"/>
+                <a:ea typeface="Arial" pitchFamily="34" charset="-122"/>
+                <a:cs typeface="Arial" pitchFamily="34" charset="-120"/>
+              </a:rPr>
+              <a:t>Quanto uma escola paga hoje</a:t>
+            </a:r>
+            <a:endParaRPr lang="en-US" sz="1500" dirty="0"/>
+          </a:p>
+        </p:txBody>
+      </p:sp>
+      <p:sp>
+        <p:nvSpPr>
+          <p:cNvPr id="7" name="Text 5"/>
+          <p:cNvSpPr txBox="1"/>
+          <p:nvPr/>
+        </p:nvSpPr>
+        <p:spPr>
+          <a:xfrm>
+            <a:off x="960120" y="4069080"/>
+            <a:ext cx="2880360" cy="320040"/>
+          </a:xfrm>
+          <a:prstGeom prst="rect">
+            <a:avLst/>
+          </a:prstGeom>
+          <a:noFill/>
+          <a:ln/>
+        </p:spPr>
+        <p:txBody>
+          <a:bodyPr wrap="square" lIns="0" tIns="0" rIns="0" bIns="0" rtlCol="0" anchor="ctr"/>
+          <a:lstStyle/>
+          <a:p>
+            <a:pPr indent="0" marL="0">
+              <a:buNone/>
+            </a:pPr>
+            <a:r>
+              <a:rPr lang="en-US" sz="1200" dirty="0">
+                <a:solidFill>
+                  <a:srgbClr val="9DB0A6"/>
+                </a:solidFill>
+                <a:latin typeface="Calibri" pitchFamily="34" charset="0"/>
+                <a:ea typeface="Calibri" pitchFamily="34" charset="-122"/>
+                <a:cs typeface="Calibri" pitchFamily="34" charset="-120"/>
+              </a:rPr>
+              <a:t>por monitoramento eletrônico</a:t>
+            </a:r>
+            <a:endParaRPr lang="en-US" sz="1200" dirty="0"/>
+          </a:p>
+        </p:txBody>
+      </p:sp>
+      <p:sp>
+        <p:nvSpPr>
+          <p:cNvPr id="8" name="Text 6"/>
+          <p:cNvSpPr txBox="1"/>
+          <p:nvPr/>
+        </p:nvSpPr>
+        <p:spPr>
+          <a:xfrm>
+            <a:off x="960120" y="4526280"/>
+            <a:ext cx="2880360" cy="411480"/>
+          </a:xfrm>
+          <a:prstGeom prst="rect">
+            <a:avLst/>
+          </a:prstGeom>
+          <a:noFill/>
+          <a:ln/>
+        </p:spPr>
+        <p:txBody>
+          <a:bodyPr wrap="square" lIns="0" tIns="0" rIns="0" bIns="0" rtlCol="0" anchor="ctr"/>
+          <a:lstStyle/>
+          <a:p>
+            <a:pPr indent="0" marL="0">
+              <a:lnSpc>
+                <a:spcPts val="1200"/>
+              </a:lnSpc>
+              <a:buNone/>
+            </a:pPr>
+            <a:r>
+              <a:rPr lang="en-US" sz="900" dirty="0">
+                <a:solidFill>
+                  <a:srgbClr val="E4572E"/>
+                </a:solidFill>
+                <a:latin typeface="Courier New" pitchFamily="34" charset="0"/>
+                <a:ea typeface="Courier New" pitchFamily="34" charset="-122"/>
+                <a:cs typeface="Courier New" pitchFamily="34" charset="-120"/>
+              </a:rPr>
+              <a:t>fonte: ligar para três escolas</a:t>
+            </a:r>
+            <a:endParaRPr lang="en-US" sz="900" dirty="0"/>
+          </a:p>
+        </p:txBody>
+      </p:sp>
+      <p:sp>
+        <p:nvSpPr>
+          <p:cNvPr id="9" name="Shape 7"/>
+          <p:cNvSpPr/>
+          <p:nvPr/>
+        </p:nvSpPr>
+        <p:spPr>
+          <a:xfrm>
+            <a:off x="4370832" y="3200400"/>
+            <a:ext cx="3410712" cy="1920240"/>
+          </a:xfrm>
+          <a:prstGeom prst="roundRect">
+            <a:avLst>
+              <a:gd name="adj" fmla="val 4762"/>
+            </a:avLst>
+          </a:prstGeom>
+          <a:solidFill>
+            <a:srgbClr val="0B100E"/>
+          </a:solidFill>
+          <a:ln w="12700">
+            <a:solidFill>
+              <a:srgbClr val="24322B"/>
+            </a:solidFill>
+            <a:prstDash val="dash"/>
+          </a:ln>
+        </p:spPr>
+      </p:sp>
+      <p:sp>
+        <p:nvSpPr>
+          <p:cNvPr id="10" name="Text 8"/>
+          <p:cNvSpPr txBox="1"/>
+          <p:nvPr/>
+        </p:nvSpPr>
+        <p:spPr>
+          <a:xfrm>
+            <a:off x="4645152" y="3456432"/>
+            <a:ext cx="2880360" cy="548640"/>
+          </a:xfrm>
+          <a:prstGeom prst="rect">
+            <a:avLst/>
+          </a:prstGeom>
+          <a:noFill/>
+          <a:ln/>
+        </p:spPr>
+        <p:txBody>
+          <a:bodyPr wrap="square" lIns="0" tIns="0" rIns="0" bIns="0" rtlCol="0" anchor="ctr"/>
+          <a:lstStyle/>
+          <a:p>
+            <a:pPr indent="0" marL="0">
+              <a:lnSpc>
+                <a:spcPts val="1900"/>
+              </a:lnSpc>
+              <a:buNone/>
+            </a:pPr>
+            <a:r>
+              <a:rPr lang="en-US" sz="1500" b="1" dirty="0">
+                <a:solidFill>
+                  <a:srgbClr val="EDF3EF"/>
+                </a:solidFill>
+                <a:latin typeface="Arial" pitchFamily="34" charset="0"/>
+                <a:ea typeface="Arial" pitchFamily="34" charset="-122"/>
+                <a:cs typeface="Arial" pitchFamily="34" charset="-120"/>
+              </a:rPr>
+              <a:t>Quantas escolas no recorte</a:t>
+            </a:r>
+            <a:endParaRPr lang="en-US" sz="1500" dirty="0"/>
+          </a:p>
+        </p:txBody>
+      </p:sp>
+      <p:sp>
+        <p:nvSpPr>
+          <p:cNvPr id="11" name="Text 9"/>
+          <p:cNvSpPr txBox="1"/>
+          <p:nvPr/>
+        </p:nvSpPr>
+        <p:spPr>
+          <a:xfrm>
+            <a:off x="4645152" y="4069080"/>
+            <a:ext cx="2880360" cy="320040"/>
+          </a:xfrm>
+          <a:prstGeom prst="rect">
+            <a:avLst/>
+          </a:prstGeom>
+          <a:noFill/>
+          <a:ln/>
+        </p:spPr>
+        <p:txBody>
+          <a:bodyPr wrap="square" lIns="0" tIns="0" rIns="0" bIns="0" rtlCol="0" anchor="ctr"/>
+          <a:lstStyle/>
+          <a:p>
+            <a:pPr indent="0" marL="0">
+              <a:buNone/>
+            </a:pPr>
+            <a:r>
+              <a:rPr lang="en-US" sz="1200" dirty="0">
+                <a:solidFill>
+                  <a:srgbClr val="9DB0A6"/>
+                </a:solidFill>
+                <a:latin typeface="Calibri" pitchFamily="34" charset="0"/>
+                <a:ea typeface="Calibri" pitchFamily="34" charset="-122"/>
+                <a:cs typeface="Calibri" pitchFamily="34" charset="-120"/>
+              </a:rPr>
+              <a:t>rede, município ou grupo</a:t>
+            </a:r>
+            <a:endParaRPr lang="en-US" sz="1200" dirty="0"/>
+          </a:p>
+        </p:txBody>
+      </p:sp>
+      <p:sp>
+        <p:nvSpPr>
+          <p:cNvPr id="12" name="Text 10"/>
+          <p:cNvSpPr txBox="1"/>
+          <p:nvPr/>
+        </p:nvSpPr>
+        <p:spPr>
+          <a:xfrm>
+            <a:off x="4645152" y="4526280"/>
+            <a:ext cx="2880360" cy="411480"/>
+          </a:xfrm>
+          <a:prstGeom prst="rect">
+            <a:avLst/>
+          </a:prstGeom>
+          <a:noFill/>
+          <a:ln/>
+        </p:spPr>
+        <p:txBody>
+          <a:bodyPr wrap="square" lIns="0" tIns="0" rIns="0" bIns="0" rtlCol="0" anchor="ctr"/>
+          <a:lstStyle/>
+          <a:p>
+            <a:pPr indent="0" marL="0">
+              <a:lnSpc>
+                <a:spcPts val="1200"/>
+              </a:lnSpc>
+              <a:buNone/>
+            </a:pPr>
+            <a:r>
+              <a:rPr lang="en-US" sz="900" dirty="0">
+                <a:solidFill>
+                  <a:srgbClr val="E4572E"/>
+                </a:solidFill>
+                <a:latin typeface="Courier New" pitchFamily="34" charset="0"/>
+                <a:ea typeface="Courier New" pitchFamily="34" charset="-122"/>
+                <a:cs typeface="Courier New" pitchFamily="34" charset="-120"/>
+              </a:rPr>
+              <a:t>fonte: Censo Escolar, INEP</a:t>
+            </a:r>
+            <a:endParaRPr lang="en-US" sz="900" dirty="0"/>
+          </a:p>
+        </p:txBody>
+      </p:sp>
+      <p:sp>
+        <p:nvSpPr>
+          <p:cNvPr id="13" name="Shape 11"/>
+          <p:cNvSpPr/>
+          <p:nvPr/>
+        </p:nvSpPr>
+        <p:spPr>
+          <a:xfrm>
+            <a:off x="8055864" y="3200400"/>
+            <a:ext cx="3410712" cy="1920240"/>
+          </a:xfrm>
+          <a:prstGeom prst="roundRect">
+            <a:avLst>
+              <a:gd name="adj" fmla="val 4762"/>
+            </a:avLst>
+          </a:prstGeom>
+          <a:solidFill>
+            <a:srgbClr val="0B100E"/>
+          </a:solidFill>
+          <a:ln w="12700">
+            <a:solidFill>
+              <a:srgbClr val="24322B"/>
+            </a:solidFill>
+            <a:prstDash val="dash"/>
+          </a:ln>
+        </p:spPr>
+      </p:sp>
+      <p:sp>
+        <p:nvSpPr>
+          <p:cNvPr id="14" name="Text 12"/>
+          <p:cNvSpPr txBox="1"/>
+          <p:nvPr/>
+        </p:nvSpPr>
+        <p:spPr>
+          <a:xfrm>
+            <a:off x="8330184" y="3456432"/>
+            <a:ext cx="2880360" cy="548640"/>
+          </a:xfrm>
+          <a:prstGeom prst="rect">
+            <a:avLst/>
+          </a:prstGeom>
+          <a:noFill/>
+          <a:ln/>
+        </p:spPr>
+        <p:txBody>
+          <a:bodyPr wrap="square" lIns="0" tIns="0" rIns="0" bIns="0" rtlCol="0" anchor="ctr"/>
+          <a:lstStyle/>
+          <a:p>
+            <a:pPr indent="0" marL="0">
+              <a:lnSpc>
+                <a:spcPts val="1900"/>
+              </a:lnSpc>
+              <a:buNone/>
+            </a:pPr>
+            <a:r>
+              <a:rPr lang="en-US" sz="1500" b="1" dirty="0">
+                <a:solidFill>
+                  <a:srgbClr val="EDF3EF"/>
+                </a:solidFill>
+                <a:latin typeface="Arial" pitchFamily="34" charset="0"/>
+                <a:ea typeface="Arial" pitchFamily="34" charset="-122"/>
+                <a:cs typeface="Arial" pitchFamily="34" charset="-120"/>
+              </a:rPr>
+              <a:t>Alertas por dia que se aguenta</a:t>
+            </a:r>
+            <a:endParaRPr lang="en-US" sz="1500" dirty="0"/>
+          </a:p>
+        </p:txBody>
+      </p:sp>
+      <p:sp>
+        <p:nvSpPr>
+          <p:cNvPr id="15" name="Text 13"/>
+          <p:cNvSpPr txBox="1"/>
+          <p:nvPr/>
+        </p:nvSpPr>
+        <p:spPr>
+          <a:xfrm>
+            <a:off x="8330184" y="4069080"/>
+            <a:ext cx="2880360" cy="320040"/>
+          </a:xfrm>
+          <a:prstGeom prst="rect">
+            <a:avLst/>
+          </a:prstGeom>
+          <a:noFill/>
+          <a:ln/>
+        </p:spPr>
+        <p:txBody>
+          <a:bodyPr wrap="square" lIns="0" tIns="0" rIns="0" bIns="0" rtlCol="0" anchor="ctr"/>
+          <a:lstStyle/>
+          <a:p>
+            <a:pPr indent="0" marL="0">
+              <a:buNone/>
+            </a:pPr>
+            <a:r>
+              <a:rPr lang="en-US" sz="1200" dirty="0">
+                <a:solidFill>
+                  <a:srgbClr val="9DB0A6"/>
+                </a:solidFill>
+                <a:latin typeface="Calibri" pitchFamily="34" charset="0"/>
+                <a:ea typeface="Calibri" pitchFamily="34" charset="-122"/>
+                <a:cs typeface="Calibri" pitchFamily="34" charset="-120"/>
+              </a:rPr>
+              <a:t>e quantos foram engano</a:t>
+            </a:r>
+            <a:endParaRPr lang="en-US" sz="1200" dirty="0"/>
+          </a:p>
+        </p:txBody>
+      </p:sp>
+      <p:sp>
+        <p:nvSpPr>
+          <p:cNvPr id="16" name="Text 14"/>
+          <p:cNvSpPr txBox="1"/>
+          <p:nvPr/>
+        </p:nvSpPr>
+        <p:spPr>
+          <a:xfrm>
+            <a:off x="8330184" y="4526280"/>
+            <a:ext cx="2880360" cy="411480"/>
+          </a:xfrm>
+          <a:prstGeom prst="rect">
+            <a:avLst/>
+          </a:prstGeom>
+          <a:noFill/>
+          <a:ln/>
+        </p:spPr>
+        <p:txBody>
+          <a:bodyPr wrap="square" lIns="0" tIns="0" rIns="0" bIns="0" rtlCol="0" anchor="ctr"/>
+          <a:lstStyle/>
+          <a:p>
+            <a:pPr indent="0" marL="0">
+              <a:lnSpc>
+                <a:spcPts val="1200"/>
+              </a:lnSpc>
+              <a:buNone/>
+            </a:pPr>
+            <a:r>
+              <a:rPr lang="en-US" sz="900" dirty="0">
+                <a:solidFill>
+                  <a:srgbClr val="E4572E"/>
+                </a:solidFill>
+                <a:latin typeface="Courier New" pitchFamily="34" charset="0"/>
+                <a:ea typeface="Courier New" pitchFamily="34" charset="-122"/>
+                <a:cs typeface="Courier New" pitchFamily="34" charset="-120"/>
+              </a:rPr>
+              <a:t>fonte: o piloto, e só ele</a:t>
+            </a:r>
+            <a:endParaRPr lang="en-US" sz="900" dirty="0"/>
+          </a:p>
+        </p:txBody>
+      </p:sp>
+      <p:sp>
+        <p:nvSpPr>
+          <p:cNvPr id="17" name="Text 15"/>
+          <p:cNvSpPr txBox="1"/>
+          <p:nvPr/>
+        </p:nvSpPr>
+        <p:spPr>
+          <a:xfrm>
+            <a:off x="685800" y="5577840"/>
+            <a:ext cx="10515600" cy="411480"/>
+          </a:xfrm>
+          <a:prstGeom prst="rect">
+            <a:avLst/>
+          </a:prstGeom>
+          <a:noFill/>
+          <a:ln/>
+        </p:spPr>
+        <p:txBody>
+          <a:bodyPr wrap="square" lIns="0" tIns="0" rIns="0" bIns="0" rtlCol="0" anchor="ctr"/>
+          <a:lstStyle/>
+          <a:p>
+            <a:pPr indent="0" marL="0">
+              <a:buNone/>
+            </a:pPr>
+            <a:r>
+              <a:rPr lang="en-US" sz="1400" i="1" dirty="0">
+                <a:solidFill>
+                  <a:srgbClr val="9DB0A6"/>
+                </a:solidFill>
+                <a:latin typeface="Calibri" pitchFamily="34" charset="0"/>
+                <a:ea typeface="Calibri" pitchFamily="34" charset="-122"/>
+                <a:cs typeface="Calibri" pitchFamily="34" charset="-120"/>
+              </a:rPr>
+              <a:t>Uma banca pergunta a fonte. “Estimativa nossa” derruba o slide, e com ele o resto da apresentação.</a:t>
+            </a:r>
+            <a:endParaRPr lang="en-US" sz="1400" dirty="0"/>
+          </a:p>
+        </p:txBody>
+      </p:sp>
+      <p:sp>
+        <p:nvSpPr>
+          <p:cNvPr id="18" name="Text 16"/>
+          <p:cNvSpPr txBox="1"/>
+          <p:nvPr/>
+        </p:nvSpPr>
+        <p:spPr>
+          <a:xfrm>
+            <a:off x="685800" y="6291072"/>
+            <a:ext cx="5486400" cy="274320"/>
+          </a:xfrm>
+          <a:prstGeom prst="rect">
+            <a:avLst/>
+          </a:prstGeom>
+          <a:noFill/>
+          <a:ln/>
+        </p:spPr>
+        <p:txBody>
+          <a:bodyPr wrap="square" lIns="0" tIns="0" rIns="0" bIns="0" rtlCol="0" anchor="ctr"/>
+          <a:lstStyle/>
+          <a:p>
+            <a:pPr indent="0" marL="0">
+              <a:buNone/>
+            </a:pPr>
+            <a:r>
+              <a:rPr lang="en-US" sz="900" dirty="0">
+                <a:solidFill>
+                  <a:srgbClr val="6A7D74"/>
+                </a:solidFill>
+                <a:latin typeface="Courier New" pitchFamily="34" charset="0"/>
+                <a:ea typeface="Courier New" pitchFamily="34" charset="-122"/>
+                <a:cs typeface="Courier New" pitchFamily="34" charset="-120"/>
+              </a:rPr>
+              <a:t>Auditix AI  ·  SVATech  ·  grupo 11</a:t>
+            </a:r>
+            <a:endParaRPr lang="en-US" sz="900" dirty="0"/>
+          </a:p>
+        </p:txBody>
+      </p:sp>
+      <p:sp>
+        <p:nvSpPr>
+          <p:cNvPr id="19" name="Text 17"/>
+          <p:cNvSpPr txBox="1"/>
+          <p:nvPr/>
+        </p:nvSpPr>
+        <p:spPr>
+          <a:xfrm>
+            <a:off x="10591495" y="6291072"/>
+            <a:ext cx="914400" cy="274320"/>
+          </a:xfrm>
+          <a:prstGeom prst="rect">
+            <a:avLst/>
+          </a:prstGeom>
+          <a:noFill/>
+          <a:ln/>
+        </p:spPr>
+        <p:txBody>
+          <a:bodyPr wrap="square" lIns="0" tIns="0" rIns="0" bIns="0" rtlCol="0" anchor="ctr"/>
+          <a:lstStyle/>
+          <a:p>
+            <a:pPr algn="r" indent="0" marL="0">
+              <a:buNone/>
+            </a:pPr>
+            <a:r>
+              <a:rPr lang="en-US" sz="900" dirty="0">
+                <a:solidFill>
+                  <a:srgbClr val="6A7D74"/>
+                </a:solidFill>
+                <a:latin typeface="Courier New" pitchFamily="34" charset="0"/>
+                <a:ea typeface="Courier New" pitchFamily="34" charset="-122"/>
+                <a:cs typeface="Courier New" pitchFamily="34" charset="-120"/>
+              </a:rPr>
+              <a:t>12</a:t>
+            </a:r>
+            <a:endParaRPr lang="en-US" sz="900" dirty="0"/>
+          </a:p>
+        </p:txBody>
+      </p:sp>
+    </p:spTree>
+  </p:cSld>
+  <p:clrMapOvr>
+    <a:masterClrMapping/>
+  </p:clrMapOvr>
+</p:sld>
+</file>
+
+<file path=ppt/slides/slide13.xml><?xml version="1.0" encoding="utf-8"?>
+<p:sld xmlns:a="http://schemas.openxmlformats.org/drawingml/2006/main" xmlns:r="http://schemas.openxmlformats.org/officeDocument/2006/relationships" xmlns:p="http://schemas.openxmlformats.org/presentationml/2006/main">
+  <p:cSld name="Slide 13">
     <p:bg>
       <p:bgPr>
         <a:solidFill>

</xml_diff>